<commit_message>
feat: reorganize Optuna tuning results into difficulty-specific directories and update presentation slides
</commit_message>
<xml_diff>
--- a/BMO-Projekt.pptx
+++ b/BMO-Projekt.pptx
@@ -5,17 +5,20 @@
     <p:sldMasterId id="2147483677" r:id="rId1"/>
   </p:sldMasterIdLst>
   <p:notesMasterIdLst>
-    <p:notesMasterId r:id="rId10"/>
+    <p:notesMasterId r:id="rId13"/>
   </p:notesMasterIdLst>
   <p:sldIdLst>
     <p:sldId id="256" r:id="rId2"/>
     <p:sldId id="257" r:id="rId3"/>
     <p:sldId id="258" r:id="rId4"/>
-    <p:sldId id="260" r:id="rId5"/>
-    <p:sldId id="261" r:id="rId6"/>
-    <p:sldId id="262" r:id="rId7"/>
-    <p:sldId id="264" r:id="rId8"/>
-    <p:sldId id="263" r:id="rId9"/>
+    <p:sldId id="261" r:id="rId5"/>
+    <p:sldId id="266" r:id="rId6"/>
+    <p:sldId id="263" r:id="rId7"/>
+    <p:sldId id="260" r:id="rId8"/>
+    <p:sldId id="265" r:id="rId9"/>
+    <p:sldId id="267" r:id="rId10"/>
+    <p:sldId id="268" r:id="rId11"/>
+    <p:sldId id="269" r:id="rId12"/>
   </p:sldIdLst>
   <p:sldSz cx="12192000" cy="6858000"/>
   <p:notesSz cx="6858000" cy="9144000"/>
@@ -125,7 +128,7 @@
 <file path=ppt/revisionInfo.xml><?xml version="1.0" encoding="utf-8"?>
 <p1510:revInfo xmlns:a="http://schemas.openxmlformats.org/drawingml/2006/main" xmlns:r="http://schemas.openxmlformats.org/officeDocument/2006/relationships" xmlns:p1510="http://schemas.microsoft.com/office/powerpoint/2015/10/main">
   <p1510:revLst>
-    <p1510:client id="{83CBDACE-3A84-4186-B9A6-AE47CA0CDA88}" v="88" dt="2026-06-20T10:22:50.765"/>
+    <p1510:client id="{83CBDACE-3A84-4186-B9A6-AE47CA0CDA88}" v="212" dt="2026-06-21T14:20:12.567"/>
   </p1510:revLst>
 </p1510:revInfo>
 </file>
@@ -135,7 +138,7 @@
   <pc:docChgLst>
     <pc:chgData name="Niko Kläsener" userId="b3580cb7-15ad-4c2f-be10-30939a475464" providerId="ADAL" clId="{36612FA6-6914-4267-9ADB-97F4291D668E}"/>
     <pc:docChg chg="undo custSel addSld delSld modSld sldOrd">
-      <pc:chgData name="Niko Kläsener" userId="b3580cb7-15ad-4c2f-be10-30939a475464" providerId="ADAL" clId="{36612FA6-6914-4267-9ADB-97F4291D668E}" dt="2026-06-20T10:23:12.042" v="514" actId="1440"/>
+      <pc:chgData name="Niko Kläsener" userId="b3580cb7-15ad-4c2f-be10-30939a475464" providerId="ADAL" clId="{36612FA6-6914-4267-9ADB-97F4291D668E}" dt="2026-06-21T14:21:08.454" v="2204" actId="20577"/>
       <pc:docMkLst>
         <pc:docMk/>
       </pc:docMkLst>
@@ -203,11 +206,19 @@
         </pc:picChg>
       </pc:sldChg>
       <pc:sldChg chg="addSp modSp mod">
-        <pc:chgData name="Niko Kläsener" userId="b3580cb7-15ad-4c2f-be10-30939a475464" providerId="ADAL" clId="{36612FA6-6914-4267-9ADB-97F4291D668E}" dt="2026-06-19T12:41:31.040" v="264" actId="17032"/>
+        <pc:chgData name="Niko Kläsener" userId="b3580cb7-15ad-4c2f-be10-30939a475464" providerId="ADAL" clId="{36612FA6-6914-4267-9ADB-97F4291D668E}" dt="2026-06-20T11:06:40.427" v="522" actId="20577"/>
         <pc:sldMkLst>
           <pc:docMk/>
           <pc:sldMk cId="313630166" sldId="257"/>
         </pc:sldMkLst>
+        <pc:spChg chg="mod">
+          <ac:chgData name="Niko Kläsener" userId="b3580cb7-15ad-4c2f-be10-30939a475464" providerId="ADAL" clId="{36612FA6-6914-4267-9ADB-97F4291D668E}" dt="2026-06-20T11:06:40.427" v="522" actId="20577"/>
+          <ac:spMkLst>
+            <pc:docMk/>
+            <pc:sldMk cId="313630166" sldId="257"/>
+            <ac:spMk id="4" creationId="{1419ED52-81D0-EE21-5D00-FADC1EFF0FD8}"/>
+          </ac:spMkLst>
+        </pc:spChg>
         <pc:spChg chg="mod">
           <ac:chgData name="Niko Kläsener" userId="b3580cb7-15ad-4c2f-be10-30939a475464" providerId="ADAL" clId="{36612FA6-6914-4267-9ADB-97F4291D668E}" dt="2026-06-19T12:26:02.010" v="144" actId="1076"/>
           <ac:spMkLst>
@@ -298,25 +309,17 @@
         </pc:cxnChg>
       </pc:sldChg>
       <pc:sldChg chg="addSp delSp modSp mod">
-        <pc:chgData name="Niko Kläsener" userId="b3580cb7-15ad-4c2f-be10-30939a475464" providerId="ADAL" clId="{36612FA6-6914-4267-9ADB-97F4291D668E}" dt="2026-06-20T10:16:37.071" v="506" actId="1076"/>
+        <pc:chgData name="Niko Kläsener" userId="b3580cb7-15ad-4c2f-be10-30939a475464" providerId="ADAL" clId="{36612FA6-6914-4267-9ADB-97F4291D668E}" dt="2026-06-21T14:02:31.331" v="1681" actId="20577"/>
         <pc:sldMkLst>
           <pc:docMk/>
           <pc:sldMk cId="1562465697" sldId="258"/>
         </pc:sldMkLst>
         <pc:spChg chg="mod">
-          <ac:chgData name="Niko Kläsener" userId="b3580cb7-15ad-4c2f-be10-30939a475464" providerId="ADAL" clId="{36612FA6-6914-4267-9ADB-97F4291D668E}" dt="2026-06-20T08:58:39.287" v="269" actId="20577"/>
+          <ac:chgData name="Niko Kläsener" userId="b3580cb7-15ad-4c2f-be10-30939a475464" providerId="ADAL" clId="{36612FA6-6914-4267-9ADB-97F4291D668E}" dt="2026-06-21T14:02:31.331" v="1681" actId="20577"/>
           <ac:spMkLst>
             <pc:docMk/>
             <pc:sldMk cId="1562465697" sldId="258"/>
             <ac:spMk id="2" creationId="{211B614C-40F6-C498-5107-17FB1AFB2B8A}"/>
-          </ac:spMkLst>
-        </pc:spChg>
-        <pc:spChg chg="del mod">
-          <ac:chgData name="Niko Kläsener" userId="b3580cb7-15ad-4c2f-be10-30939a475464" providerId="ADAL" clId="{36612FA6-6914-4267-9ADB-97F4291D668E}" dt="2026-06-19T10:47:45.152" v="26" actId="22"/>
-          <ac:spMkLst>
-            <pc:docMk/>
-            <pc:sldMk cId="1562465697" sldId="258"/>
-            <ac:spMk id="3" creationId="{9B3FC2DD-A92B-B9BD-2834-E5F4E1D8BD2D}"/>
           </ac:spMkLst>
         </pc:spChg>
         <pc:spChg chg="add mod">
@@ -327,22 +330,6 @@
             <ac:spMk id="3" creationId="{F984959B-3B96-707C-C5CF-921F9260BFDE}"/>
           </ac:spMkLst>
         </pc:spChg>
-        <pc:spChg chg="add del mod">
-          <ac:chgData name="Niko Kläsener" userId="b3580cb7-15ad-4c2f-be10-30939a475464" providerId="ADAL" clId="{36612FA6-6914-4267-9ADB-97F4291D668E}" dt="2026-06-19T15:39:33.338" v="266" actId="931"/>
-          <ac:spMkLst>
-            <pc:docMk/>
-            <pc:sldMk cId="1562465697" sldId="258"/>
-            <ac:spMk id="7" creationId="{AF6D7D65-F16E-92D0-31BE-EEDCDC63F32A}"/>
-          </ac:spMkLst>
-        </pc:spChg>
-        <pc:picChg chg="add del mod ord">
-          <ac:chgData name="Niko Kläsener" userId="b3580cb7-15ad-4c2f-be10-30939a475464" providerId="ADAL" clId="{36612FA6-6914-4267-9ADB-97F4291D668E}" dt="2026-06-19T15:38:57.529" v="265" actId="478"/>
-          <ac:picMkLst>
-            <pc:docMk/>
-            <pc:sldMk cId="1562465697" sldId="258"/>
-            <ac:picMk id="8" creationId="{28F060EB-3C4B-26C4-6CC8-CA46B6313F5B}"/>
-          </ac:picMkLst>
-        </pc:picChg>
         <pc:picChg chg="add mod ord">
           <ac:chgData name="Niko Kläsener" userId="b3580cb7-15ad-4c2f-be10-30939a475464" providerId="ADAL" clId="{36612FA6-6914-4267-9ADB-97F4291D668E}" dt="2026-06-20T10:09:03.294" v="351" actId="1076"/>
           <ac:picMkLst>
@@ -352,23 +339,8 @@
           </ac:picMkLst>
         </pc:picChg>
       </pc:sldChg>
-      <pc:sldChg chg="modSp new del mod">
-        <pc:chgData name="Niko Kläsener" userId="b3580cb7-15ad-4c2f-be10-30939a475464" providerId="ADAL" clId="{36612FA6-6914-4267-9ADB-97F4291D668E}" dt="2026-06-19T10:52:29.739" v="67" actId="47"/>
-        <pc:sldMkLst>
-          <pc:docMk/>
-          <pc:sldMk cId="746984907" sldId="259"/>
-        </pc:sldMkLst>
-        <pc:spChg chg="mod">
-          <ac:chgData name="Niko Kläsener" userId="b3580cb7-15ad-4c2f-be10-30939a475464" providerId="ADAL" clId="{36612FA6-6914-4267-9ADB-97F4291D668E}" dt="2026-06-19T10:49:35.187" v="61" actId="21"/>
-          <ac:spMkLst>
-            <pc:docMk/>
-            <pc:sldMk cId="746984907" sldId="259"/>
-            <ac:spMk id="2" creationId="{80B43282-9030-BFCE-6BD0-1526FD110A6A}"/>
-          </ac:spMkLst>
-        </pc:spChg>
-      </pc:sldChg>
-      <pc:sldChg chg="addSp delSp modSp new mod">
-        <pc:chgData name="Niko Kläsener" userId="b3580cb7-15ad-4c2f-be10-30939a475464" providerId="ADAL" clId="{36612FA6-6914-4267-9ADB-97F4291D668E}" dt="2026-06-19T10:50:28.310" v="66" actId="931"/>
+      <pc:sldChg chg="addSp delSp modSp new mod ord">
+        <pc:chgData name="Niko Kläsener" userId="b3580cb7-15ad-4c2f-be10-30939a475464" providerId="ADAL" clId="{36612FA6-6914-4267-9ADB-97F4291D668E}" dt="2026-06-21T12:28:34.308" v="530"/>
         <pc:sldMkLst>
           <pc:docMk/>
           <pc:sldMk cId="2830380807" sldId="260"/>
@@ -381,40 +353,16 @@
             <ac:spMk id="2" creationId="{4DC433D2-17BA-BB4F-88B0-0F9E964EEB21}"/>
           </ac:spMkLst>
         </pc:spChg>
-        <pc:spChg chg="del">
-          <ac:chgData name="Niko Kläsener" userId="b3580cb7-15ad-4c2f-be10-30939a475464" providerId="ADAL" clId="{36612FA6-6914-4267-9ADB-97F4291D668E}" dt="2026-06-19T10:50:01.681" v="63" actId="931"/>
-          <ac:spMkLst>
-            <pc:docMk/>
-            <pc:sldMk cId="2830380807" sldId="260"/>
-            <ac:spMk id="3" creationId="{AE507860-BF51-9992-18DF-106E6C4C923A}"/>
-          </ac:spMkLst>
-        </pc:spChg>
-        <pc:spChg chg="add del">
-          <ac:chgData name="Niko Kläsener" userId="b3580cb7-15ad-4c2f-be10-30939a475464" providerId="ADAL" clId="{36612FA6-6914-4267-9ADB-97F4291D668E}" dt="2026-06-19T10:50:28.310" v="66" actId="931"/>
-          <ac:spMkLst>
-            <pc:docMk/>
-            <pc:sldMk cId="2830380807" sldId="260"/>
-            <ac:spMk id="4" creationId="{385250F3-A37D-7ADE-19C9-371FDC47EA04}"/>
-          </ac:spMkLst>
-        </pc:spChg>
         <pc:picChg chg="add mod ord">
-          <ac:chgData name="Niko Kläsener" userId="b3580cb7-15ad-4c2f-be10-30939a475464" providerId="ADAL" clId="{36612FA6-6914-4267-9ADB-97F4291D668E}" dt="2026-06-19T10:50:01.681" v="63" actId="931"/>
+          <ac:chgData name="Niko Kläsener" userId="b3580cb7-15ad-4c2f-be10-30939a475464" providerId="ADAL" clId="{36612FA6-6914-4267-9ADB-97F4291D668E}" dt="2026-06-21T12:23:23.584" v="523" actId="14826"/>
           <ac:picMkLst>
             <pc:docMk/>
             <pc:sldMk cId="2830380807" sldId="260"/>
             <ac:picMk id="9" creationId="{B328A8BF-6F71-6DE1-E847-0E993C071748}"/>
           </ac:picMkLst>
         </pc:picChg>
-        <pc:picChg chg="add del mod ord">
-          <ac:chgData name="Niko Kläsener" userId="b3580cb7-15ad-4c2f-be10-30939a475464" providerId="ADAL" clId="{36612FA6-6914-4267-9ADB-97F4291D668E}" dt="2026-06-19T10:50:20.291" v="65" actId="931"/>
-          <ac:picMkLst>
-            <pc:docMk/>
-            <pc:sldMk cId="2830380807" sldId="260"/>
-            <ac:picMk id="11" creationId="{D9F64A39-B0E0-C0D0-1C68-4EBF29009D20}"/>
-          </ac:picMkLst>
-        </pc:picChg>
         <pc:picChg chg="add mod ord">
-          <ac:chgData name="Niko Kläsener" userId="b3580cb7-15ad-4c2f-be10-30939a475464" providerId="ADAL" clId="{36612FA6-6914-4267-9ADB-97F4291D668E}" dt="2026-06-19T10:50:28.310" v="66" actId="931"/>
+          <ac:chgData name="Niko Kläsener" userId="b3580cb7-15ad-4c2f-be10-30939a475464" providerId="ADAL" clId="{36612FA6-6914-4267-9ADB-97F4291D668E}" dt="2026-06-21T12:23:43.789" v="524" actId="14826"/>
           <ac:picMkLst>
             <pc:docMk/>
             <pc:sldMk cId="2830380807" sldId="260"/>
@@ -422,30 +370,38 @@
           </ac:picMkLst>
         </pc:picChg>
       </pc:sldChg>
-      <pc:sldChg chg="addSp delSp modSp new mod">
-        <pc:chgData name="Niko Kläsener" userId="b3580cb7-15ad-4c2f-be10-30939a475464" providerId="ADAL" clId="{36612FA6-6914-4267-9ADB-97F4291D668E}" dt="2026-06-19T10:53:54.635" v="86" actId="931"/>
+      <pc:sldChg chg="addSp delSp modSp new mod ord">
+        <pc:chgData name="Niko Kläsener" userId="b3580cb7-15ad-4c2f-be10-30939a475464" providerId="ADAL" clId="{36612FA6-6914-4267-9ADB-97F4291D668E}" dt="2026-06-21T12:44:44.495" v="714" actId="20577"/>
         <pc:sldMkLst>
           <pc:docMk/>
           <pc:sldMk cId="1179084943" sldId="261"/>
         </pc:sldMkLst>
         <pc:spChg chg="mod">
-          <ac:chgData name="Niko Kläsener" userId="b3580cb7-15ad-4c2f-be10-30939a475464" providerId="ADAL" clId="{36612FA6-6914-4267-9ADB-97F4291D668E}" dt="2026-06-19T10:53:03.614" v="85" actId="20577"/>
+          <ac:chgData name="Niko Kläsener" userId="b3580cb7-15ad-4c2f-be10-30939a475464" providerId="ADAL" clId="{36612FA6-6914-4267-9ADB-97F4291D668E}" dt="2026-06-21T12:44:44.495" v="714" actId="20577"/>
           <ac:spMkLst>
             <pc:docMk/>
             <pc:sldMk cId="1179084943" sldId="261"/>
             <ac:spMk id="2" creationId="{1E94E426-77E3-D9B2-5685-3FEAC25AD1A5}"/>
           </ac:spMkLst>
         </pc:spChg>
-        <pc:spChg chg="del">
-          <ac:chgData name="Niko Kläsener" userId="b3580cb7-15ad-4c2f-be10-30939a475464" providerId="ADAL" clId="{36612FA6-6914-4267-9ADB-97F4291D668E}" dt="2026-06-19T10:53:54.635" v="86" actId="931"/>
+        <pc:spChg chg="add mod">
+          <ac:chgData name="Niko Kläsener" userId="b3580cb7-15ad-4c2f-be10-30939a475464" providerId="ADAL" clId="{36612FA6-6914-4267-9ADB-97F4291D668E}" dt="2026-06-21T12:42:43.156" v="692" actId="113"/>
           <ac:spMkLst>
             <pc:docMk/>
             <pc:sldMk cId="1179084943" sldId="261"/>
-            <ac:spMk id="3" creationId="{2D08F052-674F-EFA1-EB75-5747051809E7}"/>
+            <ac:spMk id="3" creationId="{03B229CE-C208-3B6E-0937-5F9A9A7AA444}"/>
+          </ac:spMkLst>
+        </pc:spChg>
+        <pc:spChg chg="add mod">
+          <ac:chgData name="Niko Kläsener" userId="b3580cb7-15ad-4c2f-be10-30939a475464" providerId="ADAL" clId="{36612FA6-6914-4267-9ADB-97F4291D668E}" dt="2026-06-21T12:42:46.285" v="693" actId="113"/>
+          <ac:spMkLst>
+            <pc:docMk/>
+            <pc:sldMk cId="1179084943" sldId="261"/>
+            <ac:spMk id="7" creationId="{6FF04FC2-856E-1509-998A-C8DF92BD91DF}"/>
           </ac:spMkLst>
         </pc:spChg>
         <pc:picChg chg="add mod ord">
-          <ac:chgData name="Niko Kläsener" userId="b3580cb7-15ad-4c2f-be10-30939a475464" providerId="ADAL" clId="{36612FA6-6914-4267-9ADB-97F4291D668E}" dt="2026-06-19T10:53:54.635" v="86" actId="931"/>
+          <ac:chgData name="Niko Kläsener" userId="b3580cb7-15ad-4c2f-be10-30939a475464" providerId="ADAL" clId="{36612FA6-6914-4267-9ADB-97F4291D668E}" dt="2026-06-21T12:26:50.326" v="528" actId="1076"/>
           <ac:picMkLst>
             <pc:docMk/>
             <pc:sldMk cId="1179084943" sldId="261"/>
@@ -453,30 +409,22 @@
           </ac:picMkLst>
         </pc:picChg>
       </pc:sldChg>
-      <pc:sldChg chg="addSp delSp modSp new mod ord">
-        <pc:chgData name="Niko Kläsener" userId="b3580cb7-15ad-4c2f-be10-30939a475464" providerId="ADAL" clId="{36612FA6-6914-4267-9ADB-97F4291D668E}" dt="2026-06-19T10:58:05.492" v="123"/>
+      <pc:sldChg chg="addSp delSp modSp new add del mod ord">
+        <pc:chgData name="Niko Kläsener" userId="b3580cb7-15ad-4c2f-be10-30939a475464" providerId="ADAL" clId="{36612FA6-6914-4267-9ADB-97F4291D668E}" dt="2026-06-21T12:56:20.769" v="768" actId="47"/>
         <pc:sldMkLst>
           <pc:docMk/>
           <pc:sldMk cId="2368679576" sldId="262"/>
         </pc:sldMkLst>
         <pc:spChg chg="mod">
-          <ac:chgData name="Niko Kläsener" userId="b3580cb7-15ad-4c2f-be10-30939a475464" providerId="ADAL" clId="{36612FA6-6914-4267-9ADB-97F4291D668E}" dt="2026-06-19T10:55:04.400" v="105" actId="20577"/>
+          <ac:chgData name="Niko Kläsener" userId="b3580cb7-15ad-4c2f-be10-30939a475464" providerId="ADAL" clId="{36612FA6-6914-4267-9ADB-97F4291D668E}" dt="2026-06-21T12:56:11.809" v="766" actId="20577"/>
           <ac:spMkLst>
             <pc:docMk/>
             <pc:sldMk cId="2368679576" sldId="262"/>
             <ac:spMk id="2" creationId="{2944ED13-FD2C-1619-5816-65507A0AA985}"/>
           </ac:spMkLst>
         </pc:spChg>
-        <pc:spChg chg="del">
-          <ac:chgData name="Niko Kläsener" userId="b3580cb7-15ad-4c2f-be10-30939a475464" providerId="ADAL" clId="{36612FA6-6914-4267-9ADB-97F4291D668E}" dt="2026-06-19T10:54:53.339" v="102" actId="931"/>
-          <ac:spMkLst>
-            <pc:docMk/>
-            <pc:sldMk cId="2368679576" sldId="262"/>
-            <ac:spMk id="3" creationId="{2F562802-86AB-44D8-8F3E-18CADBC47516}"/>
-          </ac:spMkLst>
-        </pc:spChg>
         <pc:picChg chg="add mod ord">
-          <ac:chgData name="Niko Kläsener" userId="b3580cb7-15ad-4c2f-be10-30939a475464" providerId="ADAL" clId="{36612FA6-6914-4267-9ADB-97F4291D668E}" dt="2026-06-19T10:54:53.339" v="102" actId="931"/>
+          <ac:chgData name="Niko Kläsener" userId="b3580cb7-15ad-4c2f-be10-30939a475464" providerId="ADAL" clId="{36612FA6-6914-4267-9ADB-97F4291D668E}" dt="2026-06-21T12:43:35.510" v="696" actId="14826"/>
           <ac:picMkLst>
             <pc:docMk/>
             <pc:sldMk cId="2368679576" sldId="262"/>
@@ -484,30 +432,22 @@
           </ac:picMkLst>
         </pc:picChg>
       </pc:sldChg>
-      <pc:sldChg chg="addSp delSp modSp new mod">
-        <pc:chgData name="Niko Kläsener" userId="b3580cb7-15ad-4c2f-be10-30939a475464" providerId="ADAL" clId="{36612FA6-6914-4267-9ADB-97F4291D668E}" dt="2026-06-19T10:57:09.107" v="121" actId="20577"/>
+      <pc:sldChg chg="addSp delSp modSp new mod ord">
+        <pc:chgData name="Niko Kläsener" userId="b3580cb7-15ad-4c2f-be10-30939a475464" providerId="ADAL" clId="{36612FA6-6914-4267-9ADB-97F4291D668E}" dt="2026-06-21T12:44:59.951" v="718"/>
         <pc:sldMkLst>
           <pc:docMk/>
           <pc:sldMk cId="937536178" sldId="263"/>
         </pc:sldMkLst>
         <pc:spChg chg="mod">
-          <ac:chgData name="Niko Kläsener" userId="b3580cb7-15ad-4c2f-be10-30939a475464" providerId="ADAL" clId="{36612FA6-6914-4267-9ADB-97F4291D668E}" dt="2026-06-19T10:57:09.107" v="121" actId="20577"/>
+          <ac:chgData name="Niko Kläsener" userId="b3580cb7-15ad-4c2f-be10-30939a475464" providerId="ADAL" clId="{36612FA6-6914-4267-9ADB-97F4291D668E}" dt="2026-06-21T12:44:59.951" v="718"/>
           <ac:spMkLst>
             <pc:docMk/>
             <pc:sldMk cId="937536178" sldId="263"/>
             <ac:spMk id="2" creationId="{DE86CDD5-F3A8-1E49-03B4-ABAC4E69630F}"/>
           </ac:spMkLst>
         </pc:spChg>
-        <pc:spChg chg="del">
-          <ac:chgData name="Niko Kläsener" userId="b3580cb7-15ad-4c2f-be10-30939a475464" providerId="ADAL" clId="{36612FA6-6914-4267-9ADB-97F4291D668E}" dt="2026-06-19T10:56:21.822" v="117" actId="931"/>
-          <ac:spMkLst>
-            <pc:docMk/>
-            <pc:sldMk cId="937536178" sldId="263"/>
-            <ac:spMk id="3" creationId="{2FB2CE08-A8E1-8EF8-2CF5-0992FB0A6BCE}"/>
-          </ac:spMkLst>
-        </pc:spChg>
         <pc:picChg chg="add mod ord">
-          <ac:chgData name="Niko Kläsener" userId="b3580cb7-15ad-4c2f-be10-30939a475464" providerId="ADAL" clId="{36612FA6-6914-4267-9ADB-97F4291D668E}" dt="2026-06-19T10:56:21.822" v="117" actId="931"/>
+          <ac:chgData name="Niko Kläsener" userId="b3580cb7-15ad-4c2f-be10-30939a475464" providerId="ADAL" clId="{36612FA6-6914-4267-9ADB-97F4291D668E}" dt="2026-06-21T12:43:47.697" v="697" actId="14826"/>
           <ac:picMkLst>
             <pc:docMk/>
             <pc:sldMk cId="937536178" sldId="263"/>
@@ -515,34 +455,57 @@
           </ac:picMkLst>
         </pc:picChg>
       </pc:sldChg>
-      <pc:sldChg chg="addSp delSp modSp new mod">
-        <pc:chgData name="Niko Kläsener" userId="b3580cb7-15ad-4c2f-be10-30939a475464" providerId="ADAL" clId="{36612FA6-6914-4267-9ADB-97F4291D668E}" dt="2026-06-19T10:58:38.882" v="134" actId="931"/>
+      <pc:sldChg chg="addSp delSp modSp new del mod">
+        <pc:chgData name="Niko Kläsener" userId="b3580cb7-15ad-4c2f-be10-30939a475464" providerId="ADAL" clId="{36612FA6-6914-4267-9ADB-97F4291D668E}" dt="2026-06-21T12:48:17.446" v="731" actId="47"/>
         <pc:sldMkLst>
           <pc:docMk/>
           <pc:sldMk cId="673205838" sldId="264"/>
         </pc:sldMkLst>
-        <pc:spChg chg="mod">
-          <ac:chgData name="Niko Kläsener" userId="b3580cb7-15ad-4c2f-be10-30939a475464" providerId="ADAL" clId="{36612FA6-6914-4267-9ADB-97F4291D668E}" dt="2026-06-19T10:58:16.346" v="133" actId="20577"/>
-          <ac:spMkLst>
-            <pc:docMk/>
-            <pc:sldMk cId="673205838" sldId="264"/>
-            <ac:spMk id="2" creationId="{BC69C5CF-E326-767F-82D8-BC1769BEB0EA}"/>
-          </ac:spMkLst>
-        </pc:spChg>
-        <pc:spChg chg="del">
-          <ac:chgData name="Niko Kläsener" userId="b3580cb7-15ad-4c2f-be10-30939a475464" providerId="ADAL" clId="{36612FA6-6914-4267-9ADB-97F4291D668E}" dt="2026-06-19T10:58:38.882" v="134" actId="931"/>
-          <ac:spMkLst>
-            <pc:docMk/>
-            <pc:sldMk cId="673205838" sldId="264"/>
-            <ac:spMk id="3" creationId="{73810979-3BDF-194B-1F6A-B6ED29B4EE57}"/>
-          </ac:spMkLst>
-        </pc:spChg>
         <pc:picChg chg="add mod ord">
-          <ac:chgData name="Niko Kläsener" userId="b3580cb7-15ad-4c2f-be10-30939a475464" providerId="ADAL" clId="{36612FA6-6914-4267-9ADB-97F4291D668E}" dt="2026-06-19T10:58:38.882" v="134" actId="931"/>
+          <ac:chgData name="Niko Kläsener" userId="b3580cb7-15ad-4c2f-be10-30939a475464" providerId="ADAL" clId="{36612FA6-6914-4267-9ADB-97F4291D668E}" dt="2026-06-21T12:47:28.855" v="719" actId="14826"/>
           <ac:picMkLst>
             <pc:docMk/>
             <pc:sldMk cId="673205838" sldId="264"/>
             <ac:picMk id="8" creationId="{3F65DE01-F495-3DDF-820D-2838164A1E75}"/>
+          </ac:picMkLst>
+        </pc:picChg>
+      </pc:sldChg>
+      <pc:sldChg chg="modSp add mod ord">
+        <pc:chgData name="Niko Kläsener" userId="b3580cb7-15ad-4c2f-be10-30939a475464" providerId="ADAL" clId="{36612FA6-6914-4267-9ADB-97F4291D668E}" dt="2026-06-21T13:03:01.017" v="882" actId="20577"/>
+        <pc:sldMkLst>
+          <pc:docMk/>
+          <pc:sldMk cId="284479213" sldId="265"/>
+        </pc:sldMkLst>
+        <pc:spChg chg="mod">
+          <ac:chgData name="Niko Kläsener" userId="b3580cb7-15ad-4c2f-be10-30939a475464" providerId="ADAL" clId="{36612FA6-6914-4267-9ADB-97F4291D668E}" dt="2026-06-21T12:48:11.357" v="730" actId="20577"/>
+          <ac:spMkLst>
+            <pc:docMk/>
+            <pc:sldMk cId="284479213" sldId="265"/>
+            <ac:spMk id="2" creationId="{CE19303A-6C64-B42A-B22E-C575DA323E4E}"/>
+          </ac:spMkLst>
+        </pc:spChg>
+        <pc:spChg chg="mod">
+          <ac:chgData name="Niko Kläsener" userId="b3580cb7-15ad-4c2f-be10-30939a475464" providerId="ADAL" clId="{36612FA6-6914-4267-9ADB-97F4291D668E}" dt="2026-06-21T13:03:01.017" v="882" actId="20577"/>
+          <ac:spMkLst>
+            <pc:docMk/>
+            <pc:sldMk cId="284479213" sldId="265"/>
+            <ac:spMk id="3" creationId="{63281457-D136-1A63-F2D7-B4801B290DB8}"/>
+          </ac:spMkLst>
+        </pc:spChg>
+        <pc:spChg chg="mod">
+          <ac:chgData name="Niko Kläsener" userId="b3580cb7-15ad-4c2f-be10-30939a475464" providerId="ADAL" clId="{36612FA6-6914-4267-9ADB-97F4291D668E}" dt="2026-06-21T12:51:16.673" v="759" actId="20577"/>
+          <ac:spMkLst>
+            <pc:docMk/>
+            <pc:sldMk cId="284479213" sldId="265"/>
+            <ac:spMk id="7" creationId="{95B4E1EB-B5BB-3FBA-04AE-035423E7056E}"/>
+          </ac:spMkLst>
+        </pc:spChg>
+        <pc:picChg chg="mod">
+          <ac:chgData name="Niko Kläsener" userId="b3580cb7-15ad-4c2f-be10-30939a475464" providerId="ADAL" clId="{36612FA6-6914-4267-9ADB-97F4291D668E}" dt="2026-06-21T12:48:26.417" v="732" actId="14826"/>
+          <ac:picMkLst>
+            <pc:docMk/>
+            <pc:sldMk cId="284479213" sldId="265"/>
+            <ac:picMk id="8" creationId="{8BBCFB51-2DA5-DE7E-6860-BB3D133BB932}"/>
           </ac:picMkLst>
         </pc:picChg>
       </pc:sldChg>
@@ -681,6 +644,217 @@
           </ac:picMkLst>
         </pc:picChg>
       </pc:sldChg>
+      <pc:sldChg chg="delSp modSp add mod">
+        <pc:chgData name="Niko Kläsener" userId="b3580cb7-15ad-4c2f-be10-30939a475464" providerId="ADAL" clId="{36612FA6-6914-4267-9ADB-97F4291D668E}" dt="2026-06-21T13:01:29.732" v="874" actId="14100"/>
+        <pc:sldMkLst>
+          <pc:docMk/>
+          <pc:sldMk cId="1467630395" sldId="266"/>
+        </pc:sldMkLst>
+        <pc:spChg chg="mod">
+          <ac:chgData name="Niko Kläsener" userId="b3580cb7-15ad-4c2f-be10-30939a475464" providerId="ADAL" clId="{36612FA6-6914-4267-9ADB-97F4291D668E}" dt="2026-06-21T12:56:18.619" v="767"/>
+          <ac:spMkLst>
+            <pc:docMk/>
+            <pc:sldMk cId="1467630395" sldId="266"/>
+            <ac:spMk id="2" creationId="{7646B6E2-F0CF-300A-B970-C7A9A45AB3BF}"/>
+          </ac:spMkLst>
+        </pc:spChg>
+        <pc:spChg chg="mod">
+          <ac:chgData name="Niko Kläsener" userId="b3580cb7-15ad-4c2f-be10-30939a475464" providerId="ADAL" clId="{36612FA6-6914-4267-9ADB-97F4291D668E}" dt="2026-06-21T13:01:29.732" v="874" actId="14100"/>
+          <ac:spMkLst>
+            <pc:docMk/>
+            <pc:sldMk cId="1467630395" sldId="266"/>
+            <ac:spMk id="3" creationId="{BAC82BD4-2A43-8BFA-68CA-8A66C04C309B}"/>
+          </ac:spMkLst>
+        </pc:spChg>
+        <pc:spChg chg="del">
+          <ac:chgData name="Niko Kläsener" userId="b3580cb7-15ad-4c2f-be10-30939a475464" providerId="ADAL" clId="{36612FA6-6914-4267-9ADB-97F4291D668E}" dt="2026-06-21T12:56:26.621" v="769" actId="478"/>
+          <ac:spMkLst>
+            <pc:docMk/>
+            <pc:sldMk cId="1467630395" sldId="266"/>
+            <ac:spMk id="7" creationId="{657AEC3C-8D01-45F6-E8C3-FCDF8F737DEE}"/>
+          </ac:spMkLst>
+        </pc:spChg>
+        <pc:picChg chg="mod">
+          <ac:chgData name="Niko Kläsener" userId="b3580cb7-15ad-4c2f-be10-30939a475464" providerId="ADAL" clId="{36612FA6-6914-4267-9ADB-97F4291D668E}" dt="2026-06-21T12:55:59.946" v="761" actId="14826"/>
+          <ac:picMkLst>
+            <pc:docMk/>
+            <pc:sldMk cId="1467630395" sldId="266"/>
+            <ac:picMk id="8" creationId="{A712138D-C74F-6410-9202-AD79ED5D372E}"/>
+          </ac:picMkLst>
+        </pc:picChg>
+      </pc:sldChg>
+      <pc:sldChg chg="modSp new mod modClrScheme chgLayout">
+        <pc:chgData name="Niko Kläsener" userId="b3580cb7-15ad-4c2f-be10-30939a475464" providerId="ADAL" clId="{36612FA6-6914-4267-9ADB-97F4291D668E}" dt="2026-06-21T14:05:18.535" v="1732" actId="313"/>
+        <pc:sldMkLst>
+          <pc:docMk/>
+          <pc:sldMk cId="3694890744" sldId="267"/>
+        </pc:sldMkLst>
+        <pc:spChg chg="mod ord">
+          <ac:chgData name="Niko Kläsener" userId="b3580cb7-15ad-4c2f-be10-30939a475464" providerId="ADAL" clId="{36612FA6-6914-4267-9ADB-97F4291D668E}" dt="2026-06-21T14:00:29.970" v="1610" actId="700"/>
+          <ac:spMkLst>
+            <pc:docMk/>
+            <pc:sldMk cId="3694890744" sldId="267"/>
+            <ac:spMk id="2" creationId="{6BB030AB-786E-C531-12A7-749F70850164}"/>
+          </ac:spMkLst>
+        </pc:spChg>
+        <pc:spChg chg="mod ord">
+          <ac:chgData name="Niko Kläsener" userId="b3580cb7-15ad-4c2f-be10-30939a475464" providerId="ADAL" clId="{36612FA6-6914-4267-9ADB-97F4291D668E}" dt="2026-06-21T14:00:29.970" v="1610" actId="700"/>
+          <ac:spMkLst>
+            <pc:docMk/>
+            <pc:sldMk cId="3694890744" sldId="267"/>
+            <ac:spMk id="3" creationId="{F05D5584-C5F5-B21E-C1D6-CE5472F6A3BE}"/>
+          </ac:spMkLst>
+        </pc:spChg>
+        <pc:spChg chg="mod ord">
+          <ac:chgData name="Niko Kläsener" userId="b3580cb7-15ad-4c2f-be10-30939a475464" providerId="ADAL" clId="{36612FA6-6914-4267-9ADB-97F4291D668E}" dt="2026-06-21T14:04:55.247" v="1683" actId="27636"/>
+          <ac:spMkLst>
+            <pc:docMk/>
+            <pc:sldMk cId="3694890744" sldId="267"/>
+            <ac:spMk id="4" creationId="{69979646-04D1-7A25-F6AA-E780620BB2CB}"/>
+          </ac:spMkLst>
+        </pc:spChg>
+        <pc:spChg chg="mod ord">
+          <ac:chgData name="Niko Kläsener" userId="b3580cb7-15ad-4c2f-be10-30939a475464" providerId="ADAL" clId="{36612FA6-6914-4267-9ADB-97F4291D668E}" dt="2026-06-21T14:00:29.970" v="1610" actId="700"/>
+          <ac:spMkLst>
+            <pc:docMk/>
+            <pc:sldMk cId="3694890744" sldId="267"/>
+            <ac:spMk id="5" creationId="{874A7A65-C7F4-F6C9-5AE4-858DEE4E2960}"/>
+          </ac:spMkLst>
+        </pc:spChg>
+        <pc:spChg chg="mod ord">
+          <ac:chgData name="Niko Kläsener" userId="b3580cb7-15ad-4c2f-be10-30939a475464" providerId="ADAL" clId="{36612FA6-6914-4267-9ADB-97F4291D668E}" dt="2026-06-21T14:05:18.535" v="1732" actId="313"/>
+          <ac:spMkLst>
+            <pc:docMk/>
+            <pc:sldMk cId="3694890744" sldId="267"/>
+            <ac:spMk id="6" creationId="{27CF4302-EE10-DEB8-57DC-0DE63F780452}"/>
+          </ac:spMkLst>
+        </pc:spChg>
+        <pc:spChg chg="mod ord">
+          <ac:chgData name="Niko Kläsener" userId="b3580cb7-15ad-4c2f-be10-30939a475464" providerId="ADAL" clId="{36612FA6-6914-4267-9ADB-97F4291D668E}" dt="2026-06-21T14:00:29.970" v="1610" actId="700"/>
+          <ac:spMkLst>
+            <pc:docMk/>
+            <pc:sldMk cId="3694890744" sldId="267"/>
+            <ac:spMk id="7" creationId="{6B894B29-7047-1ACA-3353-24BCA1F292EB}"/>
+          </ac:spMkLst>
+        </pc:spChg>
+        <pc:spChg chg="mod ord">
+          <ac:chgData name="Niko Kläsener" userId="b3580cb7-15ad-4c2f-be10-30939a475464" providerId="ADAL" clId="{36612FA6-6914-4267-9ADB-97F4291D668E}" dt="2026-06-21T14:00:29.970" v="1610" actId="700"/>
+          <ac:spMkLst>
+            <pc:docMk/>
+            <pc:sldMk cId="3694890744" sldId="267"/>
+            <ac:spMk id="8" creationId="{5981A085-1E07-22DC-7050-E4D89C38BAD6}"/>
+          </ac:spMkLst>
+        </pc:spChg>
+        <pc:spChg chg="mod ord">
+          <ac:chgData name="Niko Kläsener" userId="b3580cb7-15ad-4c2f-be10-30939a475464" providerId="ADAL" clId="{36612FA6-6914-4267-9ADB-97F4291D668E}" dt="2026-06-21T14:00:29.970" v="1610" actId="700"/>
+          <ac:spMkLst>
+            <pc:docMk/>
+            <pc:sldMk cId="3694890744" sldId="267"/>
+            <ac:spMk id="9" creationId="{86C91C11-4729-3014-9DB3-AC8059C85536}"/>
+          </ac:spMkLst>
+        </pc:spChg>
+      </pc:sldChg>
+      <pc:sldChg chg="addSp delSp modSp new mod modClrScheme chgLayout">
+        <pc:chgData name="Niko Kläsener" userId="b3580cb7-15ad-4c2f-be10-30939a475464" providerId="ADAL" clId="{36612FA6-6914-4267-9ADB-97F4291D668E}" dt="2026-06-21T14:20:21.248" v="2172" actId="20577"/>
+        <pc:sldMkLst>
+          <pc:docMk/>
+          <pc:sldMk cId="1820629519" sldId="268"/>
+        </pc:sldMkLst>
+        <pc:spChg chg="mod ord">
+          <ac:chgData name="Niko Kläsener" userId="b3580cb7-15ad-4c2f-be10-30939a475464" providerId="ADAL" clId="{36612FA6-6914-4267-9ADB-97F4291D668E}" dt="2026-06-21T14:07:26.271" v="1734" actId="700"/>
+          <ac:spMkLst>
+            <pc:docMk/>
+            <pc:sldMk cId="1820629519" sldId="268"/>
+            <ac:spMk id="2" creationId="{F9D8922C-F139-2635-23A2-E1682F48C7CF}"/>
+          </ac:spMkLst>
+        </pc:spChg>
+        <pc:spChg chg="del mod ord">
+          <ac:chgData name="Niko Kläsener" userId="b3580cb7-15ad-4c2f-be10-30939a475464" providerId="ADAL" clId="{36612FA6-6914-4267-9ADB-97F4291D668E}" dt="2026-06-21T14:07:26.271" v="1734" actId="700"/>
+          <ac:spMkLst>
+            <pc:docMk/>
+            <pc:sldMk cId="1820629519" sldId="268"/>
+            <ac:spMk id="3" creationId="{7354009A-F498-E81D-F2D3-5E359A2B6766}"/>
+          </ac:spMkLst>
+        </pc:spChg>
+        <pc:spChg chg="mod ord">
+          <ac:chgData name="Niko Kläsener" userId="b3580cb7-15ad-4c2f-be10-30939a475464" providerId="ADAL" clId="{36612FA6-6914-4267-9ADB-97F4291D668E}" dt="2026-06-21T14:07:26.271" v="1734" actId="700"/>
+          <ac:spMkLst>
+            <pc:docMk/>
+            <pc:sldMk cId="1820629519" sldId="268"/>
+            <ac:spMk id="4" creationId="{6F5E474E-4BFF-84E5-D4B8-3A17C8B468BF}"/>
+          </ac:spMkLst>
+        </pc:spChg>
+        <pc:spChg chg="mod ord">
+          <ac:chgData name="Niko Kläsener" userId="b3580cb7-15ad-4c2f-be10-30939a475464" providerId="ADAL" clId="{36612FA6-6914-4267-9ADB-97F4291D668E}" dt="2026-06-21T14:07:26.271" v="1734" actId="700"/>
+          <ac:spMkLst>
+            <pc:docMk/>
+            <pc:sldMk cId="1820629519" sldId="268"/>
+            <ac:spMk id="5" creationId="{9424D1F4-0CF5-19F0-91ED-BF0150B57DC0}"/>
+          </ac:spMkLst>
+        </pc:spChg>
+        <pc:spChg chg="mod ord">
+          <ac:chgData name="Niko Kläsener" userId="b3580cb7-15ad-4c2f-be10-30939a475464" providerId="ADAL" clId="{36612FA6-6914-4267-9ADB-97F4291D668E}" dt="2026-06-21T14:07:26.271" v="1734" actId="700"/>
+          <ac:spMkLst>
+            <pc:docMk/>
+            <pc:sldMk cId="1820629519" sldId="268"/>
+            <ac:spMk id="6" creationId="{DA108B1F-6875-7417-1127-D7C2D703F69C}"/>
+          </ac:spMkLst>
+        </pc:spChg>
+        <pc:spChg chg="add mod ord">
+          <ac:chgData name="Niko Kläsener" userId="b3580cb7-15ad-4c2f-be10-30939a475464" providerId="ADAL" clId="{36612FA6-6914-4267-9ADB-97F4291D668E}" dt="2026-06-21T14:08:09.955" v="1765" actId="20577"/>
+          <ac:spMkLst>
+            <pc:docMk/>
+            <pc:sldMk cId="1820629519" sldId="268"/>
+            <ac:spMk id="7" creationId="{DCDECE8F-E45D-D58C-86F5-3A38622EBC18}"/>
+          </ac:spMkLst>
+        </pc:spChg>
+        <pc:spChg chg="add mod ord">
+          <ac:chgData name="Niko Kläsener" userId="b3580cb7-15ad-4c2f-be10-30939a475464" providerId="ADAL" clId="{36612FA6-6914-4267-9ADB-97F4291D668E}" dt="2026-06-21T14:14:17.066" v="1917" actId="20577"/>
+          <ac:spMkLst>
+            <pc:docMk/>
+            <pc:sldMk cId="1820629519" sldId="268"/>
+            <ac:spMk id="8" creationId="{C80A4A1F-23F8-21DA-7B98-58E1B7AA06B2}"/>
+          </ac:spMkLst>
+        </pc:spChg>
+        <pc:spChg chg="add mod ord">
+          <ac:chgData name="Niko Kläsener" userId="b3580cb7-15ad-4c2f-be10-30939a475464" providerId="ADAL" clId="{36612FA6-6914-4267-9ADB-97F4291D668E}" dt="2026-06-21T14:16:03.870" v="1959" actId="20577"/>
+          <ac:spMkLst>
+            <pc:docMk/>
+            <pc:sldMk cId="1820629519" sldId="268"/>
+            <ac:spMk id="9" creationId="{F48C21F7-4F1F-A9CE-D706-AE55B1A6DC33}"/>
+          </ac:spMkLst>
+        </pc:spChg>
+        <pc:spChg chg="add mod ord">
+          <ac:chgData name="Niko Kläsener" userId="b3580cb7-15ad-4c2f-be10-30939a475464" providerId="ADAL" clId="{36612FA6-6914-4267-9ADB-97F4291D668E}" dt="2026-06-21T14:20:21.248" v="2172" actId="20577"/>
+          <ac:spMkLst>
+            <pc:docMk/>
+            <pc:sldMk cId="1820629519" sldId="268"/>
+            <ac:spMk id="10" creationId="{806CD854-4D48-D8EB-C77B-1219067A1A42}"/>
+          </ac:spMkLst>
+        </pc:spChg>
+      </pc:sldChg>
+      <pc:sldChg chg="new del">
+        <pc:chgData name="Niko Kläsener" userId="b3580cb7-15ad-4c2f-be10-30939a475464" providerId="ADAL" clId="{36612FA6-6914-4267-9ADB-97F4291D668E}" dt="2026-06-21T13:59:58.858" v="1604" actId="47"/>
+        <pc:sldMkLst>
+          <pc:docMk/>
+          <pc:sldMk cId="2200412688" sldId="268"/>
+        </pc:sldMkLst>
+      </pc:sldChg>
+      <pc:sldChg chg="modSp new mod">
+        <pc:chgData name="Niko Kläsener" userId="b3580cb7-15ad-4c2f-be10-30939a475464" providerId="ADAL" clId="{36612FA6-6914-4267-9ADB-97F4291D668E}" dt="2026-06-21T14:21:08.454" v="2204" actId="20577"/>
+        <pc:sldMkLst>
+          <pc:docMk/>
+          <pc:sldMk cId="4209989287" sldId="269"/>
+        </pc:sldMkLst>
+        <pc:spChg chg="mod">
+          <ac:chgData name="Niko Kläsener" userId="b3580cb7-15ad-4c2f-be10-30939a475464" providerId="ADAL" clId="{36612FA6-6914-4267-9ADB-97F4291D668E}" dt="2026-06-21T14:21:08.454" v="2204" actId="20577"/>
+          <ac:spMkLst>
+            <pc:docMk/>
+            <pc:sldMk cId="4209989287" sldId="269"/>
+            <ac:spMk id="2" creationId="{9988B2A7-DB4B-CC41-E4E2-5984756E1A44}"/>
+          </ac:spMkLst>
+        </pc:spChg>
+      </pc:sldChg>
     </pc:docChg>
   </pc:docChgLst>
 </pc:chgInfo>
@@ -768,7 +942,7 @@
           <a:p>
             <a:fld id="{8BB88B2D-3E06-4D7C-A936-365E30E787AF}" type="datetimeFigureOut">
               <a:rPr lang="de-DE" smtClean="0"/>
-              <a:t>20.06.2026</a:t>
+              <a:t>21.06.2026</a:t>
             </a:fld>
             <a:endParaRPr lang="de-DE"/>
           </a:p>
@@ -4479,6 +4653,629 @@
 </p:sld>
 </file>
 
+<file path=ppt/slides/slide10.xml><?xml version="1.0" encoding="utf-8"?>
+<p:sld xmlns:a="http://schemas.openxmlformats.org/drawingml/2006/main" xmlns:r="http://schemas.openxmlformats.org/officeDocument/2006/relationships" xmlns:p="http://schemas.openxmlformats.org/presentationml/2006/main">
+  <p:cSld>
+    <p:spTree>
+      <p:nvGrpSpPr>
+        <p:cNvPr id="1" name=""/>
+        <p:cNvGrpSpPr/>
+        <p:nvPr/>
+      </p:nvGrpSpPr>
+      <p:grpSpPr>
+        <a:xfrm>
+          <a:off x="0" y="0"/>
+          <a:ext cx="0" cy="0"/>
+          <a:chOff x="0" y="0"/>
+          <a:chExt cx="0" cy="0"/>
+        </a:xfrm>
+      </p:grpSpPr>
+      <p:sp>
+        <p:nvSpPr>
+          <p:cNvPr id="2" name="Titel 1">
+            <a:extLst>
+              <a:ext uri="{FF2B5EF4-FFF2-40B4-BE49-F238E27FC236}">
+                <a16:creationId xmlns:a16="http://schemas.microsoft.com/office/drawing/2014/main" id="{F9D8922C-F139-2635-23A2-E1682F48C7CF}"/>
+              </a:ext>
+            </a:extLst>
+          </p:cNvPr>
+          <p:cNvSpPr>
+            <a:spLocks noGrp="1"/>
+          </p:cNvSpPr>
+          <p:nvPr>
+            <p:ph type="title"/>
+          </p:nvPr>
+        </p:nvSpPr>
+        <p:spPr/>
+        <p:txBody>
+          <a:bodyPr/>
+          <a:lstStyle/>
+          <a:p>
+            <a:r>
+              <a:rPr lang="de-DE" dirty="0"/>
+              <a:t>Parameter-Leitfaden für die Praxis</a:t>
+            </a:r>
+          </a:p>
+        </p:txBody>
+      </p:sp>
+      <mc:AlternateContent xmlns:mc="http://schemas.openxmlformats.org/markup-compatibility/2006">
+        <mc:Choice xmlns:a14="http://schemas.microsoft.com/office/drawing/2010/main" Requires="a14">
+          <p:sp>
+            <p:nvSpPr>
+              <p:cNvPr id="7" name="Textplatzhalter 6">
+                <a:extLst>
+                  <a:ext uri="{FF2B5EF4-FFF2-40B4-BE49-F238E27FC236}">
+                    <a16:creationId xmlns:a16="http://schemas.microsoft.com/office/drawing/2014/main" id="{DCDECE8F-E45D-D58C-86F5-3A38622EBC18}"/>
+                  </a:ext>
+                </a:extLst>
+              </p:cNvPr>
+              <p:cNvSpPr>
+                <a:spLocks noGrp="1"/>
+              </p:cNvSpPr>
+              <p:nvPr>
+                <p:ph type="body" idx="1"/>
+              </p:nvPr>
+            </p:nvSpPr>
+            <p:spPr/>
+            <p:txBody>
+              <a:bodyPr/>
+              <a:lstStyle/>
+              <a:p>
+                <a:r>
+                  <a:rPr lang="de-DE" dirty="0">
+                    <a:ea typeface="Cambria Math" panose="02040503050406030204" pitchFamily="18" charset="0"/>
+                  </a:rPr>
+                  <a:t>Wahl von </a:t>
+                </a:r>
+                <a14:m>
+                  <m:oMath xmlns:m="http://schemas.openxmlformats.org/officeDocument/2006/math">
+                    <m:r>
+                      <a:rPr lang="de-DE" i="1" smtClean="0">
+                        <a:latin typeface="Cambria Math" panose="02040503050406030204" pitchFamily="18" charset="0"/>
+                        <a:ea typeface="Cambria Math" panose="02040503050406030204" pitchFamily="18" charset="0"/>
+                      </a:rPr>
+                      <m:t>𝜶</m:t>
+                    </m:r>
+                  </m:oMath>
+                </a14:m>
+                <a:r>
+                  <a:rPr lang="de-DE" dirty="0"/>
+                  <a:t> und </a:t>
+                </a:r>
+                <a14:m>
+                  <m:oMath xmlns:m="http://schemas.openxmlformats.org/officeDocument/2006/math">
+                    <m:r>
+                      <a:rPr lang="de-DE" i="1" smtClean="0">
+                        <a:latin typeface="Cambria Math" panose="02040503050406030204" pitchFamily="18" charset="0"/>
+                        <a:ea typeface="Cambria Math" panose="02040503050406030204" pitchFamily="18" charset="0"/>
+                      </a:rPr>
+                      <m:t>𝜷</m:t>
+                    </m:r>
+                  </m:oMath>
+                </a14:m>
+                <a:endParaRPr lang="de-DE" dirty="0"/>
+              </a:p>
+            </p:txBody>
+          </p:sp>
+        </mc:Choice>
+        <mc:Fallback>
+          <p:sp>
+            <p:nvSpPr>
+              <p:cNvPr id="7" name="Textplatzhalter 6">
+                <a:extLst>
+                  <a:ext uri="{FF2B5EF4-FFF2-40B4-BE49-F238E27FC236}">
+                    <a16:creationId xmlns:a16="http://schemas.microsoft.com/office/drawing/2014/main" id="{DCDECE8F-E45D-D58C-86F5-3A38622EBC18}"/>
+                  </a:ext>
+                </a:extLst>
+              </p:cNvPr>
+              <p:cNvSpPr>
+                <a:spLocks noGrp="1" noRot="1" noChangeAspect="1" noMove="1" noResize="1" noEditPoints="1" noAdjustHandles="1" noChangeArrowheads="1" noChangeShapeType="1" noTextEdit="1"/>
+              </p:cNvSpPr>
+              <p:nvPr>
+                <p:ph type="body" idx="1"/>
+              </p:nvPr>
+            </p:nvSpPr>
+            <p:spPr>
+              <a:blipFill>
+                <a:blip r:embed="rId2"/>
+                <a:stretch>
+                  <a:fillRect l="-1891" b="-17778"/>
+                </a:stretch>
+              </a:blipFill>
+            </p:spPr>
+            <p:txBody>
+              <a:bodyPr/>
+              <a:lstStyle/>
+              <a:p>
+                <a:r>
+                  <a:rPr lang="de-DE">
+                    <a:noFill/>
+                  </a:rPr>
+                  <a:t> </a:t>
+                </a:r>
+              </a:p>
+            </p:txBody>
+          </p:sp>
+        </mc:Fallback>
+      </mc:AlternateContent>
+      <mc:AlternateContent xmlns:mc="http://schemas.openxmlformats.org/markup-compatibility/2006">
+        <mc:Choice xmlns:a14="http://schemas.microsoft.com/office/drawing/2010/main" Requires="a14">
+          <p:sp>
+            <p:nvSpPr>
+              <p:cNvPr id="8" name="Inhaltsplatzhalter 7">
+                <a:extLst>
+                  <a:ext uri="{FF2B5EF4-FFF2-40B4-BE49-F238E27FC236}">
+                    <a16:creationId xmlns:a16="http://schemas.microsoft.com/office/drawing/2014/main" id="{C80A4A1F-23F8-21DA-7B98-58E1B7AA06B2}"/>
+                  </a:ext>
+                </a:extLst>
+              </p:cNvPr>
+              <p:cNvSpPr>
+                <a:spLocks noGrp="1"/>
+              </p:cNvSpPr>
+              <p:nvPr>
+                <p:ph sz="half" idx="2"/>
+              </p:nvPr>
+            </p:nvSpPr>
+            <p:spPr/>
+            <p:txBody>
+              <a:bodyPr/>
+              <a:lstStyle/>
+              <a:p>
+                <a:pPr>
+                  <a:buFont typeface="Wingdings" panose="05000000000000000000" pitchFamily="2" charset="2"/>
+                  <a:buChar char="§"/>
+                </a:pPr>
+                <a14:m>
+                  <m:oMath xmlns:m="http://schemas.openxmlformats.org/officeDocument/2006/math">
+                    <m:r>
+                      <a:rPr lang="de-DE" i="1" smtClean="0">
+                        <a:latin typeface="Cambria Math" panose="02040503050406030204" pitchFamily="18" charset="0"/>
+                        <a:ea typeface="Cambria Math" panose="02040503050406030204" pitchFamily="18" charset="0"/>
+                      </a:rPr>
+                      <m:t>𝜶</m:t>
+                    </m:r>
+                  </m:oMath>
+                </a14:m>
+                <a:r>
+                  <a:rPr lang="de-DE" dirty="0"/>
+                  <a:t> Bereiche [1 bis 2]</a:t>
+                </a:r>
+              </a:p>
+              <a:p>
+                <a:pPr lvl="1">
+                  <a:buFont typeface="Wingdings" panose="05000000000000000000" pitchFamily="2" charset="2"/>
+                  <a:buChar char="§"/>
+                </a:pPr>
+                <a:r>
+                  <a:rPr lang="de-DE" dirty="0"/>
+                  <a:t>Groß </a:t>
+                </a:r>
+                <a:r>
+                  <a:rPr lang="de-DE" dirty="0">
+                    <a:cs typeface="Courier New" panose="02070309020205020404" pitchFamily="49" charset="0"/>
+                  </a:rPr>
+                  <a:t>→ </a:t>
+                </a:r>
+                <a:r>
+                  <a:rPr lang="de-DE" dirty="0"/>
+                  <a:t>Schnelle Konvergenz (einfache Probleme)</a:t>
+                </a:r>
+              </a:p>
+              <a:p>
+                <a:pPr lvl="1">
+                  <a:buFont typeface="Wingdings" panose="05000000000000000000" pitchFamily="2" charset="2"/>
+                  <a:buChar char="§"/>
+                </a:pPr>
+                <a:r>
+                  <a:rPr lang="de-DE" dirty="0"/>
+                  <a:t>Klein </a:t>
+                </a:r>
+                <a:r>
+                  <a:rPr lang="de-DE" dirty="0">
+                    <a:cs typeface="Courier New" panose="02070309020205020404" pitchFamily="49" charset="0"/>
+                  </a:rPr>
+                  <a:t>→ </a:t>
+                </a:r>
+                <a:r>
+                  <a:rPr lang="de-DE" dirty="0"/>
+                  <a:t>mehr Exploration (komplexer Probleme)</a:t>
+                </a:r>
+              </a:p>
+              <a:p>
+                <a:pPr>
+                  <a:buFont typeface="Wingdings" panose="05000000000000000000" pitchFamily="2" charset="2"/>
+                  <a:buChar char="§"/>
+                </a:pPr>
+                <a14:m>
+                  <m:oMath xmlns:m="http://schemas.openxmlformats.org/officeDocument/2006/math">
+                    <m:r>
+                      <a:rPr lang="de-DE" i="1">
+                        <a:latin typeface="Cambria Math" panose="02040503050406030204" pitchFamily="18" charset="0"/>
+                        <a:ea typeface="Cambria Math" panose="02040503050406030204" pitchFamily="18" charset="0"/>
+                      </a:rPr>
+                      <m:t>𝜷</m:t>
+                    </m:r>
+                  </m:oMath>
+                </a14:m>
+                <a:r>
+                  <a:rPr lang="de-DE" dirty="0"/>
+                  <a:t> Bereiche [2 bis 5]</a:t>
+                </a:r>
+              </a:p>
+              <a:p>
+                <a:pPr lvl="1">
+                  <a:buFont typeface="Wingdings" panose="05000000000000000000" pitchFamily="2" charset="2"/>
+                  <a:buChar char="§"/>
+                </a:pPr>
+                <a:r>
+                  <a:rPr lang="de-DE" dirty="0"/>
+                  <a:t>Groß </a:t>
+                </a:r>
+                <a:r>
+                  <a:rPr lang="de-DE" dirty="0">
+                    <a:cs typeface="Courier New" panose="02070309020205020404" pitchFamily="49" charset="0"/>
+                  </a:rPr>
+                  <a:t>→  </a:t>
+                </a:r>
+                <a:r>
+                  <a:rPr lang="de-DE" dirty="0"/>
+                  <a:t>Hoher Selektionsdruck (kleine Effizienzunterschieden)</a:t>
+                </a:r>
+              </a:p>
+              <a:p>
+                <a:pPr lvl="1">
+                  <a:buFont typeface="Wingdings" panose="05000000000000000000" pitchFamily="2" charset="2"/>
+                  <a:buChar char="§"/>
+                </a:pPr>
+                <a:r>
+                  <a:rPr lang="de-DE" dirty="0"/>
+                  <a:t>Klein </a:t>
+                </a:r>
+                <a:r>
+                  <a:rPr lang="de-DE" dirty="0">
+                    <a:cs typeface="Courier New" panose="02070309020205020404" pitchFamily="49" charset="0"/>
+                  </a:rPr>
+                  <a:t>→</a:t>
+                </a:r>
+                <a:r>
+                  <a:rPr lang="de-DE" dirty="0"/>
+                  <a:t> mehr Exploration</a:t>
+                </a:r>
+              </a:p>
+            </p:txBody>
+          </p:sp>
+        </mc:Choice>
+        <mc:Fallback>
+          <p:sp>
+            <p:nvSpPr>
+              <p:cNvPr id="8" name="Inhaltsplatzhalter 7">
+                <a:extLst>
+                  <a:ext uri="{FF2B5EF4-FFF2-40B4-BE49-F238E27FC236}">
+                    <a16:creationId xmlns:a16="http://schemas.microsoft.com/office/drawing/2014/main" id="{C80A4A1F-23F8-21DA-7B98-58E1B7AA06B2}"/>
+                  </a:ext>
+                </a:extLst>
+              </p:cNvPr>
+              <p:cNvSpPr>
+                <a:spLocks noGrp="1" noRot="1" noChangeAspect="1" noMove="1" noResize="1" noEditPoints="1" noAdjustHandles="1" noChangeArrowheads="1" noChangeShapeType="1" noTextEdit="1"/>
+              </p:cNvSpPr>
+              <p:nvPr>
+                <p:ph sz="half" idx="2"/>
+              </p:nvPr>
+            </p:nvSpPr>
+            <p:spPr>
+              <a:blipFill>
+                <a:blip r:embed="rId3"/>
+                <a:stretch>
+                  <a:fillRect t="-2980" b="-166"/>
+                </a:stretch>
+              </a:blipFill>
+            </p:spPr>
+            <p:txBody>
+              <a:bodyPr/>
+              <a:lstStyle/>
+              <a:p>
+                <a:r>
+                  <a:rPr lang="de-DE">
+                    <a:noFill/>
+                  </a:rPr>
+                  <a:t> </a:t>
+                </a:r>
+              </a:p>
+            </p:txBody>
+          </p:sp>
+        </mc:Fallback>
+      </mc:AlternateContent>
+      <p:sp>
+        <p:nvSpPr>
+          <p:cNvPr id="9" name="Textplatzhalter 8">
+            <a:extLst>
+              <a:ext uri="{FF2B5EF4-FFF2-40B4-BE49-F238E27FC236}">
+                <a16:creationId xmlns:a16="http://schemas.microsoft.com/office/drawing/2014/main" id="{F48C21F7-4F1F-A9CE-D706-AE55B1A6DC33}"/>
+              </a:ext>
+            </a:extLst>
+          </p:cNvPr>
+          <p:cNvSpPr>
+            <a:spLocks noGrp="1"/>
+          </p:cNvSpPr>
+          <p:nvPr>
+            <p:ph type="body" sz="quarter" idx="3"/>
+          </p:nvPr>
+        </p:nvSpPr>
+        <p:spPr/>
+        <p:txBody>
+          <a:bodyPr/>
+          <a:lstStyle/>
+          <a:p>
+            <a:r>
+              <a:rPr lang="de-DE" dirty="0"/>
+              <a:t>Wahl von Gruppengröße und Verdunstungsrate</a:t>
+            </a:r>
+          </a:p>
+        </p:txBody>
+      </p:sp>
+      <p:sp>
+        <p:nvSpPr>
+          <p:cNvPr id="10" name="Inhaltsplatzhalter 9">
+            <a:extLst>
+              <a:ext uri="{FF2B5EF4-FFF2-40B4-BE49-F238E27FC236}">
+                <a16:creationId xmlns:a16="http://schemas.microsoft.com/office/drawing/2014/main" id="{806CD854-4D48-D8EB-C77B-1219067A1A42}"/>
+              </a:ext>
+            </a:extLst>
+          </p:cNvPr>
+          <p:cNvSpPr>
+            <a:spLocks noGrp="1"/>
+          </p:cNvSpPr>
+          <p:nvPr>
+            <p:ph sz="quarter" idx="4"/>
+          </p:nvPr>
+        </p:nvSpPr>
+        <p:spPr/>
+        <p:txBody>
+          <a:bodyPr/>
+          <a:lstStyle/>
+          <a:p>
+            <a:pPr>
+              <a:buFont typeface="Wingdings" panose="05000000000000000000" pitchFamily="2" charset="2"/>
+              <a:buChar char="§"/>
+            </a:pPr>
+            <a:r>
+              <a:rPr lang="de-DE" dirty="0"/>
+              <a:t>Gruppengröße</a:t>
+            </a:r>
+          </a:p>
+          <a:p>
+            <a:pPr lvl="1">
+              <a:buFont typeface="Wingdings" panose="05000000000000000000" pitchFamily="2" charset="2"/>
+              <a:buChar char="§"/>
+            </a:pPr>
+            <a:r>
+              <a:rPr lang="de-DE" dirty="0"/>
+              <a:t>Große Gruppen bringen </a:t>
+            </a:r>
+            <a:r>
+              <a:rPr lang="de-DE" dirty="0">
+                <a:cs typeface="Courier New" panose="02070309020205020404" pitchFamily="49" charset="0"/>
+              </a:rPr>
+              <a:t>mehr Varianz pro Iteration aber Rechenintensiver</a:t>
+            </a:r>
+          </a:p>
+          <a:p>
+            <a:pPr>
+              <a:buFont typeface="Wingdings" panose="05000000000000000000" pitchFamily="2" charset="2"/>
+              <a:buChar char="§"/>
+            </a:pPr>
+            <a:r>
+              <a:rPr lang="de-DE" dirty="0"/>
+              <a:t>Verdunstungsrate</a:t>
+            </a:r>
+          </a:p>
+          <a:p>
+            <a:pPr lvl="1">
+              <a:buFont typeface="Wingdings" panose="05000000000000000000" pitchFamily="2" charset="2"/>
+              <a:buChar char="§"/>
+            </a:pPr>
+            <a:r>
+              <a:rPr lang="de-DE" dirty="0">
+                <a:cs typeface="Courier New" panose="02070309020205020404" pitchFamily="49" charset="0"/>
+              </a:rPr>
+              <a:t>Groß → mehr Exploration</a:t>
+            </a:r>
+          </a:p>
+          <a:p>
+            <a:pPr lvl="1">
+              <a:buFont typeface="Wingdings" panose="05000000000000000000" pitchFamily="2" charset="2"/>
+              <a:buChar char="§"/>
+            </a:pPr>
+            <a:r>
+              <a:rPr lang="de-DE" dirty="0">
+                <a:cs typeface="Courier New" panose="02070309020205020404" pitchFamily="49" charset="0"/>
+              </a:rPr>
+              <a:t>Klein → schnellere Konvergenz</a:t>
+            </a:r>
+          </a:p>
+        </p:txBody>
+      </p:sp>
+      <p:sp>
+        <p:nvSpPr>
+          <p:cNvPr id="4" name="Datumsplatzhalter 3">
+            <a:extLst>
+              <a:ext uri="{FF2B5EF4-FFF2-40B4-BE49-F238E27FC236}">
+                <a16:creationId xmlns:a16="http://schemas.microsoft.com/office/drawing/2014/main" id="{6F5E474E-4BFF-84E5-D4B8-3A17C8B468BF}"/>
+              </a:ext>
+            </a:extLst>
+          </p:cNvPr>
+          <p:cNvSpPr>
+            <a:spLocks noGrp="1"/>
+          </p:cNvSpPr>
+          <p:nvPr>
+            <p:ph type="dt" sz="half" idx="10"/>
+          </p:nvPr>
+        </p:nvSpPr>
+        <p:spPr/>
+        <p:txBody>
+          <a:bodyPr/>
+          <a:lstStyle/>
+          <a:p>
+            <a:r>
+              <a:rPr lang="de-DE"/>
+              <a:t>22.03.2025</a:t>
+            </a:r>
+          </a:p>
+        </p:txBody>
+      </p:sp>
+      <p:sp>
+        <p:nvSpPr>
+          <p:cNvPr id="5" name="Fußzeilenplatzhalter 4">
+            <a:extLst>
+              <a:ext uri="{FF2B5EF4-FFF2-40B4-BE49-F238E27FC236}">
+                <a16:creationId xmlns:a16="http://schemas.microsoft.com/office/drawing/2014/main" id="{9424D1F4-0CF5-19F0-91ED-BF0150B57DC0}"/>
+              </a:ext>
+            </a:extLst>
+          </p:cNvPr>
+          <p:cNvSpPr>
+            <a:spLocks noGrp="1"/>
+          </p:cNvSpPr>
+          <p:nvPr>
+            <p:ph type="ftr" sz="quarter" idx="11"/>
+          </p:nvPr>
+        </p:nvSpPr>
+        <p:spPr/>
+        <p:txBody>
+          <a:bodyPr/>
+          <a:lstStyle/>
+          <a:p>
+            <a:r>
+              <a:rPr lang="de-DE"/>
+              <a:t>Niko Kläsener</a:t>
+            </a:r>
+          </a:p>
+        </p:txBody>
+      </p:sp>
+      <p:sp>
+        <p:nvSpPr>
+          <p:cNvPr id="6" name="Foliennummernplatzhalter 5">
+            <a:extLst>
+              <a:ext uri="{FF2B5EF4-FFF2-40B4-BE49-F238E27FC236}">
+                <a16:creationId xmlns:a16="http://schemas.microsoft.com/office/drawing/2014/main" id="{DA108B1F-6875-7417-1127-D7C2D703F69C}"/>
+              </a:ext>
+            </a:extLst>
+          </p:cNvPr>
+          <p:cNvSpPr>
+            <a:spLocks noGrp="1"/>
+          </p:cNvSpPr>
+          <p:nvPr>
+            <p:ph type="sldNum" sz="quarter" idx="12"/>
+          </p:nvPr>
+        </p:nvSpPr>
+        <p:spPr/>
+        <p:txBody>
+          <a:bodyPr/>
+          <a:lstStyle/>
+          <a:p>
+            <a:fld id="{F20E45F0-5197-4D99-A0B0-CC09E9235134}" type="slidenum">
+              <a:rPr lang="de-DE" smtClean="0"/>
+              <a:t>10</a:t>
+            </a:fld>
+            <a:endParaRPr lang="de-DE"/>
+          </a:p>
+        </p:txBody>
+      </p:sp>
+    </p:spTree>
+    <p:extLst>
+      <p:ext uri="{BB962C8B-B14F-4D97-AF65-F5344CB8AC3E}">
+        <p14:creationId xmlns:p14="http://schemas.microsoft.com/office/powerpoint/2010/main" val="1820629519"/>
+      </p:ext>
+    </p:extLst>
+  </p:cSld>
+  <p:clrMapOvr>
+    <a:masterClrMapping/>
+  </p:clrMapOvr>
+</p:sld>
+</file>
+
+<file path=ppt/slides/slide11.xml><?xml version="1.0" encoding="utf-8"?>
+<p:sld xmlns:a="http://schemas.openxmlformats.org/drawingml/2006/main" xmlns:r="http://schemas.openxmlformats.org/officeDocument/2006/relationships" xmlns:p="http://schemas.openxmlformats.org/presentationml/2006/main">
+  <p:cSld>
+    <p:spTree>
+      <p:nvGrpSpPr>
+        <p:cNvPr id="1" name=""/>
+        <p:cNvGrpSpPr/>
+        <p:nvPr/>
+      </p:nvGrpSpPr>
+      <p:grpSpPr>
+        <a:xfrm>
+          <a:off x="0" y="0"/>
+          <a:ext cx="0" cy="0"/>
+          <a:chOff x="0" y="0"/>
+          <a:chExt cx="0" cy="0"/>
+        </a:xfrm>
+      </p:grpSpPr>
+      <p:sp>
+        <p:nvSpPr>
+          <p:cNvPr id="2" name="Titel 1">
+            <a:extLst>
+              <a:ext uri="{FF2B5EF4-FFF2-40B4-BE49-F238E27FC236}">
+                <a16:creationId xmlns:a16="http://schemas.microsoft.com/office/drawing/2014/main" id="{9988B2A7-DB4B-CC41-E4E2-5984756E1A44}"/>
+              </a:ext>
+            </a:extLst>
+          </p:cNvPr>
+          <p:cNvSpPr>
+            <a:spLocks noGrp="1"/>
+          </p:cNvSpPr>
+          <p:nvPr>
+            <p:ph type="ctrTitle"/>
+          </p:nvPr>
+        </p:nvSpPr>
+        <p:spPr/>
+        <p:txBody>
+          <a:bodyPr/>
+          <a:lstStyle/>
+          <a:p>
+            <a:r>
+              <a:rPr lang="de-DE" dirty="0"/>
+              <a:t>Danke für eure Aufmerksamkeit</a:t>
+            </a:r>
+          </a:p>
+        </p:txBody>
+      </p:sp>
+      <p:sp>
+        <p:nvSpPr>
+          <p:cNvPr id="3" name="Untertitel 2">
+            <a:extLst>
+              <a:ext uri="{FF2B5EF4-FFF2-40B4-BE49-F238E27FC236}">
+                <a16:creationId xmlns:a16="http://schemas.microsoft.com/office/drawing/2014/main" id="{6F32734D-9E88-F3F9-5F07-603128EBE54B}"/>
+              </a:ext>
+            </a:extLst>
+          </p:cNvPr>
+          <p:cNvSpPr>
+            <a:spLocks noGrp="1"/>
+          </p:cNvSpPr>
+          <p:nvPr>
+            <p:ph type="subTitle" idx="1"/>
+          </p:nvPr>
+        </p:nvSpPr>
+        <p:spPr/>
+        <p:txBody>
+          <a:bodyPr/>
+          <a:lstStyle/>
+          <a:p>
+            <a:endParaRPr lang="de-DE"/>
+          </a:p>
+        </p:txBody>
+      </p:sp>
+    </p:spTree>
+    <p:extLst>
+      <p:ext uri="{BB962C8B-B14F-4D97-AF65-F5344CB8AC3E}">
+        <p14:creationId xmlns:p14="http://schemas.microsoft.com/office/powerpoint/2010/main" val="4209989287"/>
+      </p:ext>
+    </p:extLst>
+  </p:cSld>
+  <p:clrMapOvr>
+    <a:masterClrMapping/>
+  </p:clrMapOvr>
+</p:sld>
+</file>
+
 <file path=ppt/slides/slide2.xml><?xml version="1.0" encoding="utf-8"?>
 <p:sld xmlns:a="http://schemas.openxmlformats.org/drawingml/2006/main" xmlns:r="http://schemas.openxmlformats.org/officeDocument/2006/relationships" xmlns:p="http://schemas.openxmlformats.org/presentationml/2006/main">
   <p:cSld>
@@ -4547,8 +5344,9 @@
           <a:p>
             <a:r>
               <a:rPr lang="de-DE"/>
-              <a:t>22.03.2025</a:t>
-            </a:r>
+              <a:t>20.06.2026</a:t>
+            </a:r>
+            <a:endParaRPr lang="de-DE" dirty="0"/>
           </a:p>
         </p:txBody>
       </p:sp>
@@ -6256,7 +7054,7 @@
           <a:p>
             <a:r>
               <a:rPr lang="de-DE" dirty="0"/>
-              <a:t>NMGE-Generator</a:t>
+              <a:t>Problem-Generator</a:t>
             </a:r>
           </a:p>
         </p:txBody>
@@ -6488,7 +7286,7 @@
           <p:cNvPr id="2" name="Titel 1">
             <a:extLst>
               <a:ext uri="{FF2B5EF4-FFF2-40B4-BE49-F238E27FC236}">
-                <a16:creationId xmlns:a16="http://schemas.microsoft.com/office/drawing/2014/main" id="{4DC433D2-17BA-BB4F-88B0-0F9E964EEB21}"/>
+                <a16:creationId xmlns:a16="http://schemas.microsoft.com/office/drawing/2014/main" id="{1E94E426-77E3-D9B2-5685-3FEAC25AD1A5}"/>
               </a:ext>
             </a:extLst>
           </p:cNvPr>
@@ -6506,17 +7304,17 @@
           <a:p>
             <a:r>
               <a:rPr lang="de-DE" dirty="0"/>
-              <a:t>Haupteffekt und Wechselwirkung</a:t>
+              <a:t>Nutzwertvergleich Hard-Problem</a:t>
             </a:r>
           </a:p>
         </p:txBody>
       </p:sp>
       <p:pic>
         <p:nvPicPr>
-          <p:cNvPr id="9" name="Inhaltsplatzhalter 8">
-            <a:extLst>
-              <a:ext uri="{FF2B5EF4-FFF2-40B4-BE49-F238E27FC236}">
-                <a16:creationId xmlns:a16="http://schemas.microsoft.com/office/drawing/2014/main" id="{B328A8BF-6F71-6DE1-E847-0E993C071748}"/>
+          <p:cNvPr id="8" name="Inhaltsplatzhalter 7">
+            <a:extLst>
+              <a:ext uri="{FF2B5EF4-FFF2-40B4-BE49-F238E27FC236}">
+                <a16:creationId xmlns:a16="http://schemas.microsoft.com/office/drawing/2014/main" id="{4DAC7E66-EB2C-45E1-5D4F-7CAE9DCE4400}"/>
               </a:ext>
             </a:extLst>
           </p:cNvPr>
@@ -6524,7 +7322,7 @@
             <a:picLocks noGrp="1" noChangeAspect="1"/>
           </p:cNvPicPr>
           <p:nvPr>
-            <p:ph sz="half" idx="1"/>
+            <p:ph idx="1"/>
           </p:nvPr>
         </p:nvPicPr>
         <p:blipFill>
@@ -6535,64 +7333,25 @@
               </a:ext>
             </a:extLst>
           </a:blip>
-          <a:stretch>
-            <a:fillRect/>
-          </a:stretch>
+          <a:srcRect/>
+          <a:stretch/>
         </p:blipFill>
         <p:spPr>
           <a:xfrm>
-            <a:off x="838200" y="2117449"/>
-            <a:ext cx="5181600" cy="3767689"/>
+            <a:off x="838200" y="1847850"/>
+            <a:ext cx="6834718" cy="4351338"/>
           </a:xfrm>
           <a:prstGeom prst="rect">
             <a:avLst/>
           </a:prstGeom>
         </p:spPr>
       </p:pic>
-      <p:pic>
-        <p:nvPicPr>
-          <p:cNvPr id="13" name="Inhaltsplatzhalter 12">
-            <a:extLst>
-              <a:ext uri="{FF2B5EF4-FFF2-40B4-BE49-F238E27FC236}">
-                <a16:creationId xmlns:a16="http://schemas.microsoft.com/office/drawing/2014/main" id="{60767B9F-4700-514B-860F-8A88677FBA11}"/>
-              </a:ext>
-            </a:extLst>
-          </p:cNvPr>
-          <p:cNvPicPr>
-            <a:picLocks noGrp="1" noChangeAspect="1"/>
-          </p:cNvPicPr>
-          <p:nvPr>
-            <p:ph sz="half" idx="2"/>
-          </p:nvPr>
-        </p:nvPicPr>
-        <p:blipFill>
-          <a:blip r:embed="rId3">
-            <a:extLst>
-              <a:ext uri="{28A0092B-C50C-407E-A947-70E740481C1C}">
-                <a14:useLocalDpi xmlns:a14="http://schemas.microsoft.com/office/drawing/2010/main" val="0"/>
-              </a:ext>
-            </a:extLst>
-          </a:blip>
-          <a:stretch>
-            <a:fillRect/>
-          </a:stretch>
-        </p:blipFill>
-        <p:spPr>
-          <a:xfrm>
-            <a:off x="6458667" y="1825625"/>
-            <a:ext cx="4608666" cy="4351338"/>
-          </a:xfrm>
-          <a:prstGeom prst="rect">
-            <a:avLst/>
-          </a:prstGeom>
-        </p:spPr>
-      </p:pic>
-      <p:sp>
-        <p:nvSpPr>
-          <p:cNvPr id="5" name="Datumsplatzhalter 4">
-            <a:extLst>
-              <a:ext uri="{FF2B5EF4-FFF2-40B4-BE49-F238E27FC236}">
-                <a16:creationId xmlns:a16="http://schemas.microsoft.com/office/drawing/2014/main" id="{49DDB7FE-35AB-EF95-B844-395AC8BC38E1}"/>
+      <p:sp>
+        <p:nvSpPr>
+          <p:cNvPr id="4" name="Datumsplatzhalter 3">
+            <a:extLst>
+              <a:ext uri="{FF2B5EF4-FFF2-40B4-BE49-F238E27FC236}">
+                <a16:creationId xmlns:a16="http://schemas.microsoft.com/office/drawing/2014/main" id="{C4D0D370-05E6-ED99-91A0-C31BE3C76117}"/>
               </a:ext>
             </a:extLst>
           </p:cNvPr>
@@ -6617,10 +7376,10 @@
       </p:sp>
       <p:sp>
         <p:nvSpPr>
-          <p:cNvPr id="6" name="Fußzeilenplatzhalter 5">
-            <a:extLst>
-              <a:ext uri="{FF2B5EF4-FFF2-40B4-BE49-F238E27FC236}">
-                <a16:creationId xmlns:a16="http://schemas.microsoft.com/office/drawing/2014/main" id="{51E9CE6C-8D9D-6C84-AF97-59F2D4CA9933}"/>
+          <p:cNvPr id="5" name="Fußzeilenplatzhalter 4">
+            <a:extLst>
+              <a:ext uri="{FF2B5EF4-FFF2-40B4-BE49-F238E27FC236}">
+                <a16:creationId xmlns:a16="http://schemas.microsoft.com/office/drawing/2014/main" id="{EE5A90F7-118B-2BCF-4C7E-E756DF23D5F5}"/>
               </a:ext>
             </a:extLst>
           </p:cNvPr>
@@ -6645,10 +7404,10 @@
       </p:sp>
       <p:sp>
         <p:nvSpPr>
-          <p:cNvPr id="7" name="Foliennummernplatzhalter 6">
-            <a:extLst>
-              <a:ext uri="{FF2B5EF4-FFF2-40B4-BE49-F238E27FC236}">
-                <a16:creationId xmlns:a16="http://schemas.microsoft.com/office/drawing/2014/main" id="{04D53141-76EE-66A9-336D-DEC63BE99CDE}"/>
+          <p:cNvPr id="6" name="Foliennummernplatzhalter 5">
+            <a:extLst>
+              <a:ext uri="{FF2B5EF4-FFF2-40B4-BE49-F238E27FC236}">
+                <a16:creationId xmlns:a16="http://schemas.microsoft.com/office/drawing/2014/main" id="{22096C79-41ED-F127-04E6-1D1CB2E4DA20}"/>
               </a:ext>
             </a:extLst>
           </p:cNvPr>
@@ -6672,10 +7431,147 @@
           </a:p>
         </p:txBody>
       </p:sp>
+      <p:sp>
+        <p:nvSpPr>
+          <p:cNvPr id="3" name="Textfeld 2">
+            <a:extLst>
+              <a:ext uri="{FF2B5EF4-FFF2-40B4-BE49-F238E27FC236}">
+                <a16:creationId xmlns:a16="http://schemas.microsoft.com/office/drawing/2014/main" id="{03B229CE-C208-3B6E-0937-5F9A9A7AA444}"/>
+              </a:ext>
+            </a:extLst>
+          </p:cNvPr>
+          <p:cNvSpPr txBox="1"/>
+          <p:nvPr/>
+        </p:nvSpPr>
+        <p:spPr>
+          <a:xfrm>
+            <a:off x="8153400" y="2606109"/>
+            <a:ext cx="2990850" cy="1200329"/>
+          </a:xfrm>
+          <a:prstGeom prst="rect">
+            <a:avLst/>
+          </a:prstGeom>
+          <a:noFill/>
+        </p:spPr>
+        <p:txBody>
+          <a:bodyPr wrap="square" rtlCol="0">
+            <a:spAutoFit/>
+          </a:bodyPr>
+          <a:lstStyle/>
+          <a:p>
+            <a:r>
+              <a:rPr lang="de-DE" b="1" dirty="0"/>
+              <a:t>Hard-Problem:</a:t>
+            </a:r>
+          </a:p>
+          <a:p>
+            <a:pPr marL="285750" indent="-285750">
+              <a:buFont typeface="Wingdings" panose="05000000000000000000" pitchFamily="2" charset="2"/>
+              <a:buChar char="§"/>
+            </a:pPr>
+            <a:r>
+              <a:rPr lang="de-DE" b="1" dirty="0"/>
+              <a:t>800 Items</a:t>
+            </a:r>
+          </a:p>
+          <a:p>
+            <a:pPr marL="285750" indent="-285750">
+              <a:buFont typeface="Wingdings" panose="05000000000000000000" pitchFamily="2" charset="2"/>
+              <a:buChar char="§"/>
+            </a:pPr>
+            <a:r>
+              <a:rPr lang="de-DE" b="1" dirty="0"/>
+              <a:t>1.000.000 Kapazität</a:t>
+            </a:r>
+          </a:p>
+          <a:p>
+            <a:pPr marL="285750" indent="-285750">
+              <a:buFont typeface="Wingdings" panose="05000000000000000000" pitchFamily="2" charset="2"/>
+              <a:buChar char="§"/>
+            </a:pPr>
+            <a:r>
+              <a:rPr lang="de-DE" b="1" dirty="0"/>
+              <a:t>14 Gruppen</a:t>
+            </a:r>
+          </a:p>
+        </p:txBody>
+      </p:sp>
+      <p:sp>
+        <p:nvSpPr>
+          <p:cNvPr id="7" name="Textfeld 6">
+            <a:extLst>
+              <a:ext uri="{FF2B5EF4-FFF2-40B4-BE49-F238E27FC236}">
+                <a16:creationId xmlns:a16="http://schemas.microsoft.com/office/drawing/2014/main" id="{6FF04FC2-856E-1509-998A-C8DF92BD91DF}"/>
+              </a:ext>
+            </a:extLst>
+          </p:cNvPr>
+          <p:cNvSpPr txBox="1"/>
+          <p:nvPr/>
+        </p:nvSpPr>
+        <p:spPr>
+          <a:xfrm>
+            <a:off x="8153400" y="4240600"/>
+            <a:ext cx="3409950" cy="1477328"/>
+          </a:xfrm>
+          <a:prstGeom prst="rect">
+            <a:avLst/>
+          </a:prstGeom>
+          <a:noFill/>
+        </p:spPr>
+        <p:txBody>
+          <a:bodyPr wrap="square" rtlCol="0">
+            <a:spAutoFit/>
+          </a:bodyPr>
+          <a:lstStyle/>
+          <a:p>
+            <a:r>
+              <a:rPr lang="de-DE" b="1" dirty="0"/>
+              <a:t>Ergebnis:</a:t>
+            </a:r>
+          </a:p>
+          <a:p>
+            <a:pPr marL="285750" indent="-285750">
+              <a:buFont typeface="Wingdings" panose="05000000000000000000" pitchFamily="2" charset="2"/>
+              <a:buChar char="§"/>
+            </a:pPr>
+            <a:r>
+              <a:rPr lang="de-DE" b="1" dirty="0"/>
+              <a:t>Beste: 	99,91%</a:t>
+            </a:r>
+          </a:p>
+          <a:p>
+            <a:pPr marL="285750" indent="-285750">
+              <a:buFont typeface="Wingdings" panose="05000000000000000000" pitchFamily="2" charset="2"/>
+              <a:buChar char="§"/>
+            </a:pPr>
+            <a:r>
+              <a:rPr lang="de-DE" b="1" dirty="0"/>
+              <a:t>Mittlere: 	99,76%</a:t>
+            </a:r>
+          </a:p>
+          <a:p>
+            <a:pPr marL="285750" indent="-285750">
+              <a:buFont typeface="Wingdings" panose="05000000000000000000" pitchFamily="2" charset="2"/>
+              <a:buChar char="§"/>
+            </a:pPr>
+            <a:r>
+              <a:rPr lang="de-DE" b="1" dirty="0"/>
+              <a:t>Schlechteste:	99,61%</a:t>
+            </a:r>
+          </a:p>
+          <a:p>
+            <a:pPr marL="285750" indent="-285750">
+              <a:buFont typeface="Wingdings" panose="05000000000000000000" pitchFamily="2" charset="2"/>
+              <a:buChar char="§"/>
+            </a:pPr>
+            <a:endParaRPr lang="de-DE" dirty="0"/>
+          </a:p>
+        </p:txBody>
+      </p:sp>
     </p:spTree>
     <p:extLst>
       <p:ext uri="{BB962C8B-B14F-4D97-AF65-F5344CB8AC3E}">
-        <p14:creationId xmlns:p14="http://schemas.microsoft.com/office/powerpoint/2010/main" val="2830380807"/>
+        <p14:creationId xmlns:p14="http://schemas.microsoft.com/office/powerpoint/2010/main" val="1179084943"/>
       </p:ext>
     </p:extLst>
   </p:cSld>
@@ -6690,7 +7586,13 @@
   <p:cSld>
     <p:spTree>
       <p:nvGrpSpPr>
-        <p:cNvPr id="1" name=""/>
+        <p:cNvPr id="1" name="">
+          <a:extLst>
+            <a:ext uri="{FF2B5EF4-FFF2-40B4-BE49-F238E27FC236}">
+              <a16:creationId xmlns:a16="http://schemas.microsoft.com/office/drawing/2014/main" id="{539A691F-89F8-9257-7DFE-81993F064A02}"/>
+            </a:ext>
+          </a:extLst>
+        </p:cNvPr>
         <p:cNvGrpSpPr/>
         <p:nvPr/>
       </p:nvGrpSpPr>
@@ -6707,7 +7609,7 @@
           <p:cNvPr id="2" name="Titel 1">
             <a:extLst>
               <a:ext uri="{FF2B5EF4-FFF2-40B4-BE49-F238E27FC236}">
-                <a16:creationId xmlns:a16="http://schemas.microsoft.com/office/drawing/2014/main" id="{1E94E426-77E3-D9B2-5685-3FEAC25AD1A5}"/>
+                <a16:creationId xmlns:a16="http://schemas.microsoft.com/office/drawing/2014/main" id="{7646B6E2-F0CF-300A-B970-C7A9A45AB3BF}"/>
               </a:ext>
             </a:extLst>
           </p:cNvPr>
@@ -6724,8 +7626,12 @@
           <a:lstStyle/>
           <a:p>
             <a:r>
+              <a:rPr lang="de-DE" dirty="0" err="1"/>
+              <a:t>Pheromonspur</a:t>
+            </a:r>
+            <a:r>
               <a:rPr lang="de-DE" dirty="0"/>
-              <a:t>Nutzwertvergleich</a:t>
+              <a:t> Hard-Problem</a:t>
             </a:r>
           </a:p>
         </p:txBody>
@@ -6735,7 +7641,7 @@
           <p:cNvPr id="8" name="Inhaltsplatzhalter 7">
             <a:extLst>
               <a:ext uri="{FF2B5EF4-FFF2-40B4-BE49-F238E27FC236}">
-                <a16:creationId xmlns:a16="http://schemas.microsoft.com/office/drawing/2014/main" id="{4DAC7E66-EB2C-45E1-5D4F-7CAE9DCE4400}"/>
+                <a16:creationId xmlns:a16="http://schemas.microsoft.com/office/drawing/2014/main" id="{A712138D-C74F-6410-9202-AD79ED5D372E}"/>
               </a:ext>
             </a:extLst>
           </p:cNvPr>
@@ -6754,13 +7660,12 @@
               </a:ext>
             </a:extLst>
           </a:blip>
-          <a:stretch>
-            <a:fillRect/>
-          </a:stretch>
+          <a:srcRect/>
+          <a:stretch/>
         </p:blipFill>
         <p:spPr>
           <a:xfrm>
-            <a:off x="2678641" y="1825625"/>
+            <a:off x="838200" y="1847850"/>
             <a:ext cx="6834718" cy="4351338"/>
           </a:xfrm>
           <a:prstGeom prst="rect">
@@ -6773,7 +7678,7 @@
           <p:cNvPr id="4" name="Datumsplatzhalter 3">
             <a:extLst>
               <a:ext uri="{FF2B5EF4-FFF2-40B4-BE49-F238E27FC236}">
-                <a16:creationId xmlns:a16="http://schemas.microsoft.com/office/drawing/2014/main" id="{C4D0D370-05E6-ED99-91A0-C31BE3C76117}"/>
+                <a16:creationId xmlns:a16="http://schemas.microsoft.com/office/drawing/2014/main" id="{E1CB6DE3-71E5-AD25-8856-D7436362A2D0}"/>
               </a:ext>
             </a:extLst>
           </p:cNvPr>
@@ -6801,7 +7706,7 @@
           <p:cNvPr id="5" name="Fußzeilenplatzhalter 4">
             <a:extLst>
               <a:ext uri="{FF2B5EF4-FFF2-40B4-BE49-F238E27FC236}">
-                <a16:creationId xmlns:a16="http://schemas.microsoft.com/office/drawing/2014/main" id="{EE5A90F7-118B-2BCF-4C7E-E756DF23D5F5}"/>
+                <a16:creationId xmlns:a16="http://schemas.microsoft.com/office/drawing/2014/main" id="{3BF510ED-BBA5-8623-B450-6B31E67874B1}"/>
               </a:ext>
             </a:extLst>
           </p:cNvPr>
@@ -6829,7 +7734,7 @@
           <p:cNvPr id="6" name="Foliennummernplatzhalter 5">
             <a:extLst>
               <a:ext uri="{FF2B5EF4-FFF2-40B4-BE49-F238E27FC236}">
-                <a16:creationId xmlns:a16="http://schemas.microsoft.com/office/drawing/2014/main" id="{22096C79-41ED-F127-04E6-1D1CB2E4DA20}"/>
+                <a16:creationId xmlns:a16="http://schemas.microsoft.com/office/drawing/2014/main" id="{E317FD82-72F2-654A-06E1-930DE87D5D56}"/>
               </a:ext>
             </a:extLst>
           </p:cNvPr>
@@ -6853,10 +7758,98 @@
           </a:p>
         </p:txBody>
       </p:sp>
+      <p:sp>
+        <p:nvSpPr>
+          <p:cNvPr id="3" name="Textfeld 2">
+            <a:extLst>
+              <a:ext uri="{FF2B5EF4-FFF2-40B4-BE49-F238E27FC236}">
+                <a16:creationId xmlns:a16="http://schemas.microsoft.com/office/drawing/2014/main" id="{BAC82BD4-2A43-8BFA-68CA-8A66C04C309B}"/>
+              </a:ext>
+            </a:extLst>
+          </p:cNvPr>
+          <p:cNvSpPr txBox="1"/>
+          <p:nvPr/>
+        </p:nvSpPr>
+        <p:spPr>
+          <a:xfrm>
+            <a:off x="8153400" y="2606109"/>
+            <a:ext cx="3200400" cy="2308324"/>
+          </a:xfrm>
+          <a:prstGeom prst="rect">
+            <a:avLst/>
+          </a:prstGeom>
+          <a:noFill/>
+        </p:spPr>
+        <p:txBody>
+          <a:bodyPr wrap="square" rtlCol="0">
+            <a:spAutoFit/>
+          </a:bodyPr>
+          <a:lstStyle/>
+          <a:p>
+            <a:r>
+              <a:rPr lang="de-DE" b="1" dirty="0"/>
+              <a:t>Beste: </a:t>
+            </a:r>
+          </a:p>
+          <a:p>
+            <a:pPr marL="285750" indent="-285750">
+              <a:buFont typeface="Wingdings" panose="05000000000000000000" pitchFamily="2" charset="2"/>
+              <a:buChar char="§"/>
+            </a:pPr>
+            <a:r>
+              <a:rPr lang="de-DE" b="1" dirty="0"/>
+              <a:t>Fokussiert auf die Kleinstgegenstände</a:t>
+            </a:r>
+          </a:p>
+          <a:p>
+            <a:pPr marL="285750" indent="-285750">
+              <a:buFont typeface="Wingdings" panose="05000000000000000000" pitchFamily="2" charset="2"/>
+              <a:buChar char="§"/>
+            </a:pPr>
+            <a:r>
+              <a:rPr lang="de-DE" b="1" dirty="0"/>
+              <a:t>hohes Stagnationsrisiko</a:t>
+            </a:r>
+          </a:p>
+          <a:p>
+            <a:endParaRPr lang="de-DE" b="1" dirty="0"/>
+          </a:p>
+          <a:p>
+            <a:r>
+              <a:rPr lang="de-DE" b="1" dirty="0"/>
+              <a:t>Schlechteste:</a:t>
+            </a:r>
+          </a:p>
+          <a:p>
+            <a:pPr marL="285750" indent="-285750">
+              <a:buFont typeface="Wingdings" panose="05000000000000000000" pitchFamily="2" charset="2"/>
+              <a:buChar char="§"/>
+            </a:pPr>
+            <a:r>
+              <a:rPr lang="de-DE" b="1" dirty="0"/>
+              <a:t> mehr Exploration</a:t>
+            </a:r>
+          </a:p>
+          <a:p>
+            <a:pPr marL="285750" indent="-285750">
+              <a:buFont typeface="Wingdings" panose="05000000000000000000" pitchFamily="2" charset="2"/>
+              <a:buChar char="§"/>
+            </a:pPr>
+            <a:r>
+              <a:rPr lang="de-DE" dirty="0"/>
+              <a:t> </a:t>
+            </a:r>
+            <a:r>
+              <a:rPr lang="de-DE" b="1" dirty="0"/>
+              <a:t>stabileres Suchverhalten</a:t>
+            </a:r>
+          </a:p>
+        </p:txBody>
+      </p:sp>
     </p:spTree>
     <p:extLst>
       <p:ext uri="{BB962C8B-B14F-4D97-AF65-F5344CB8AC3E}">
-        <p14:creationId xmlns:p14="http://schemas.microsoft.com/office/powerpoint/2010/main" val="1179084943"/>
+        <p14:creationId xmlns:p14="http://schemas.microsoft.com/office/powerpoint/2010/main" val="1467630395"/>
       </p:ext>
     </p:extLst>
   </p:cSld>
@@ -6888,7 +7881,7 @@
           <p:cNvPr id="2" name="Titel 1">
             <a:extLst>
               <a:ext uri="{FF2B5EF4-FFF2-40B4-BE49-F238E27FC236}">
-                <a16:creationId xmlns:a16="http://schemas.microsoft.com/office/drawing/2014/main" id="{2944ED13-FD2C-1619-5816-65507A0AA985}"/>
+                <a16:creationId xmlns:a16="http://schemas.microsoft.com/office/drawing/2014/main" id="{DE86CDD5-F3A8-1E49-03B4-ABAC4E69630F}"/>
               </a:ext>
             </a:extLst>
           </p:cNvPr>
@@ -6906,7 +7899,7 @@
           <a:p>
             <a:r>
               <a:rPr lang="de-DE" dirty="0"/>
-              <a:t>Pheromon-Spur</a:t>
+              <a:t>Item-Auswahl Hard-Problem</a:t>
             </a:r>
           </a:p>
         </p:txBody>
@@ -6916,7 +7909,7 @@
           <p:cNvPr id="8" name="Inhaltsplatzhalter 7">
             <a:extLst>
               <a:ext uri="{FF2B5EF4-FFF2-40B4-BE49-F238E27FC236}">
-                <a16:creationId xmlns:a16="http://schemas.microsoft.com/office/drawing/2014/main" id="{AD463835-8BB8-FEE2-98D6-EA9C01C3A6A5}"/>
+                <a16:creationId xmlns:a16="http://schemas.microsoft.com/office/drawing/2014/main" id="{CCD849A5-AE97-5B6A-16ED-2BC4C72CF5BC}"/>
               </a:ext>
             </a:extLst>
           </p:cNvPr>
@@ -6935,14 +7928,13 @@
               </a:ext>
             </a:extLst>
           </a:blip>
-          <a:stretch>
-            <a:fillRect/>
-          </a:stretch>
+          <a:srcRect/>
+          <a:stretch/>
         </p:blipFill>
         <p:spPr>
           <a:xfrm>
-            <a:off x="2462690" y="1825625"/>
-            <a:ext cx="7266620" cy="4351338"/>
+            <a:off x="1059100" y="1825625"/>
+            <a:ext cx="10073799" cy="4351338"/>
           </a:xfrm>
           <a:prstGeom prst="rect">
             <a:avLst/>
@@ -6954,7 +7946,7 @@
           <p:cNvPr id="4" name="Datumsplatzhalter 3">
             <a:extLst>
               <a:ext uri="{FF2B5EF4-FFF2-40B4-BE49-F238E27FC236}">
-                <a16:creationId xmlns:a16="http://schemas.microsoft.com/office/drawing/2014/main" id="{0FD0B66D-B1AF-FF2B-AA67-0A44FCED8CB2}"/>
+                <a16:creationId xmlns:a16="http://schemas.microsoft.com/office/drawing/2014/main" id="{E50407AF-A5BD-50CE-FDF3-BF40706A411F}"/>
               </a:ext>
             </a:extLst>
           </p:cNvPr>
@@ -6982,7 +7974,7 @@
           <p:cNvPr id="5" name="Fußzeilenplatzhalter 4">
             <a:extLst>
               <a:ext uri="{FF2B5EF4-FFF2-40B4-BE49-F238E27FC236}">
-                <a16:creationId xmlns:a16="http://schemas.microsoft.com/office/drawing/2014/main" id="{52CE3654-1830-9153-F0BC-119C24F1E811}"/>
+                <a16:creationId xmlns:a16="http://schemas.microsoft.com/office/drawing/2014/main" id="{7411A53B-319E-FD54-9E3B-908627BD44F5}"/>
               </a:ext>
             </a:extLst>
           </p:cNvPr>
@@ -7010,7 +8002,7 @@
           <p:cNvPr id="6" name="Foliennummernplatzhalter 5">
             <a:extLst>
               <a:ext uri="{FF2B5EF4-FFF2-40B4-BE49-F238E27FC236}">
-                <a16:creationId xmlns:a16="http://schemas.microsoft.com/office/drawing/2014/main" id="{2F698665-41AC-4B3F-FB3F-093EF9113738}"/>
+                <a16:creationId xmlns:a16="http://schemas.microsoft.com/office/drawing/2014/main" id="{FE1E8DB6-4C98-C632-D75C-05F38D93E9EB}"/>
               </a:ext>
             </a:extLst>
           </p:cNvPr>
@@ -7037,7 +8029,7 @@
     </p:spTree>
     <p:extLst>
       <p:ext uri="{BB962C8B-B14F-4D97-AF65-F5344CB8AC3E}">
-        <p14:creationId xmlns:p14="http://schemas.microsoft.com/office/powerpoint/2010/main" val="2368679576"/>
+        <p14:creationId xmlns:p14="http://schemas.microsoft.com/office/powerpoint/2010/main" val="937536178"/>
       </p:ext>
     </p:extLst>
   </p:cSld>
@@ -7069,7 +8061,7 @@
           <p:cNvPr id="2" name="Titel 1">
             <a:extLst>
               <a:ext uri="{FF2B5EF4-FFF2-40B4-BE49-F238E27FC236}">
-                <a16:creationId xmlns:a16="http://schemas.microsoft.com/office/drawing/2014/main" id="{BC69C5CF-E326-767F-82D8-BC1769BEB0EA}"/>
+                <a16:creationId xmlns:a16="http://schemas.microsoft.com/office/drawing/2014/main" id="{4DC433D2-17BA-BB4F-88B0-0F9E964EEB21}"/>
               </a:ext>
             </a:extLst>
           </p:cNvPr>
@@ -7087,17 +8079,17 @@
           <a:p>
             <a:r>
               <a:rPr lang="de-DE" dirty="0"/>
-              <a:t>Paradoxon</a:t>
+              <a:t>Haupteffekt und Wechselwirkung</a:t>
             </a:r>
           </a:p>
         </p:txBody>
       </p:sp>
       <p:pic>
         <p:nvPicPr>
-          <p:cNvPr id="8" name="Inhaltsplatzhalter 7">
-            <a:extLst>
-              <a:ext uri="{FF2B5EF4-FFF2-40B4-BE49-F238E27FC236}">
-                <a16:creationId xmlns:a16="http://schemas.microsoft.com/office/drawing/2014/main" id="{3F65DE01-F495-3DDF-820D-2838164A1E75}"/>
+          <p:cNvPr id="9" name="Inhaltsplatzhalter 8">
+            <a:extLst>
+              <a:ext uri="{FF2B5EF4-FFF2-40B4-BE49-F238E27FC236}">
+                <a16:creationId xmlns:a16="http://schemas.microsoft.com/office/drawing/2014/main" id="{B328A8BF-6F71-6DE1-E847-0E993C071748}"/>
               </a:ext>
             </a:extLst>
           </p:cNvPr>
@@ -7105,7 +8097,7 @@
             <a:picLocks noGrp="1" noChangeAspect="1"/>
           </p:cNvPicPr>
           <p:nvPr>
-            <p:ph idx="1"/>
+            <p:ph sz="half" idx="1"/>
           </p:nvPr>
         </p:nvPicPr>
         <p:blipFill>
@@ -7116,26 +8108,62 @@
               </a:ext>
             </a:extLst>
           </a:blip>
-          <a:stretch>
-            <a:fillRect/>
-          </a:stretch>
+          <a:srcRect/>
+          <a:stretch/>
         </p:blipFill>
         <p:spPr>
           <a:xfrm>
-            <a:off x="2678641" y="1825625"/>
-            <a:ext cx="6834718" cy="4351338"/>
+            <a:off x="838200" y="2117449"/>
+            <a:ext cx="5181600" cy="3767689"/>
           </a:xfrm>
           <a:prstGeom prst="rect">
             <a:avLst/>
           </a:prstGeom>
         </p:spPr>
       </p:pic>
-      <p:sp>
-        <p:nvSpPr>
-          <p:cNvPr id="4" name="Datumsplatzhalter 3">
-            <a:extLst>
-              <a:ext uri="{FF2B5EF4-FFF2-40B4-BE49-F238E27FC236}">
-                <a16:creationId xmlns:a16="http://schemas.microsoft.com/office/drawing/2014/main" id="{B4719940-190C-899F-641A-5583A2F374FA}"/>
+      <p:pic>
+        <p:nvPicPr>
+          <p:cNvPr id="13" name="Inhaltsplatzhalter 12">
+            <a:extLst>
+              <a:ext uri="{FF2B5EF4-FFF2-40B4-BE49-F238E27FC236}">
+                <a16:creationId xmlns:a16="http://schemas.microsoft.com/office/drawing/2014/main" id="{60767B9F-4700-514B-860F-8A88677FBA11}"/>
+              </a:ext>
+            </a:extLst>
+          </p:cNvPr>
+          <p:cNvPicPr>
+            <a:picLocks noGrp="1" noChangeAspect="1"/>
+          </p:cNvPicPr>
+          <p:nvPr>
+            <p:ph sz="half" idx="2"/>
+          </p:nvPr>
+        </p:nvPicPr>
+        <p:blipFill>
+          <a:blip r:embed="rId3">
+            <a:extLst>
+              <a:ext uri="{28A0092B-C50C-407E-A947-70E740481C1C}">
+                <a14:useLocalDpi xmlns:a14="http://schemas.microsoft.com/office/drawing/2010/main" val="0"/>
+              </a:ext>
+            </a:extLst>
+          </a:blip>
+          <a:srcRect/>
+          <a:stretch/>
+        </p:blipFill>
+        <p:spPr>
+          <a:xfrm>
+            <a:off x="6458667" y="1825625"/>
+            <a:ext cx="4608666" cy="4351338"/>
+          </a:xfrm>
+          <a:prstGeom prst="rect">
+            <a:avLst/>
+          </a:prstGeom>
+        </p:spPr>
+      </p:pic>
+      <p:sp>
+        <p:nvSpPr>
+          <p:cNvPr id="5" name="Datumsplatzhalter 4">
+            <a:extLst>
+              <a:ext uri="{FF2B5EF4-FFF2-40B4-BE49-F238E27FC236}">
+                <a16:creationId xmlns:a16="http://schemas.microsoft.com/office/drawing/2014/main" id="{49DDB7FE-35AB-EF95-B844-395AC8BC38E1}"/>
               </a:ext>
             </a:extLst>
           </p:cNvPr>
@@ -7160,10 +8188,10 @@
       </p:sp>
       <p:sp>
         <p:nvSpPr>
-          <p:cNvPr id="5" name="Fußzeilenplatzhalter 4">
-            <a:extLst>
-              <a:ext uri="{FF2B5EF4-FFF2-40B4-BE49-F238E27FC236}">
-                <a16:creationId xmlns:a16="http://schemas.microsoft.com/office/drawing/2014/main" id="{C8A8E5CA-7FDF-D981-EE10-57056068BB34}"/>
+          <p:cNvPr id="6" name="Fußzeilenplatzhalter 5">
+            <a:extLst>
+              <a:ext uri="{FF2B5EF4-FFF2-40B4-BE49-F238E27FC236}">
+                <a16:creationId xmlns:a16="http://schemas.microsoft.com/office/drawing/2014/main" id="{51E9CE6C-8D9D-6C84-AF97-59F2D4CA9933}"/>
               </a:ext>
             </a:extLst>
           </p:cNvPr>
@@ -7188,10 +8216,10 @@
       </p:sp>
       <p:sp>
         <p:nvSpPr>
-          <p:cNvPr id="6" name="Foliennummernplatzhalter 5">
-            <a:extLst>
-              <a:ext uri="{FF2B5EF4-FFF2-40B4-BE49-F238E27FC236}">
-                <a16:creationId xmlns:a16="http://schemas.microsoft.com/office/drawing/2014/main" id="{BA2FF3FE-05C3-8AAD-B8EC-7D699F867802}"/>
+          <p:cNvPr id="7" name="Foliennummernplatzhalter 6">
+            <a:extLst>
+              <a:ext uri="{FF2B5EF4-FFF2-40B4-BE49-F238E27FC236}">
+                <a16:creationId xmlns:a16="http://schemas.microsoft.com/office/drawing/2014/main" id="{04D53141-76EE-66A9-336D-DEC63BE99CDE}"/>
               </a:ext>
             </a:extLst>
           </p:cNvPr>
@@ -7218,7 +8246,7 @@
     </p:spTree>
     <p:extLst>
       <p:ext uri="{BB962C8B-B14F-4D97-AF65-F5344CB8AC3E}">
-        <p14:creationId xmlns:p14="http://schemas.microsoft.com/office/powerpoint/2010/main" val="673205838"/>
+        <p14:creationId xmlns:p14="http://schemas.microsoft.com/office/powerpoint/2010/main" val="2830380807"/>
       </p:ext>
     </p:extLst>
   </p:cSld>
@@ -7229,6 +8257,329 @@
 </file>
 
 <file path=ppt/slides/slide8.xml><?xml version="1.0" encoding="utf-8"?>
+<p:sld xmlns:a="http://schemas.openxmlformats.org/drawingml/2006/main" xmlns:r="http://schemas.openxmlformats.org/officeDocument/2006/relationships" xmlns:p="http://schemas.openxmlformats.org/presentationml/2006/main">
+  <p:cSld>
+    <p:spTree>
+      <p:nvGrpSpPr>
+        <p:cNvPr id="1" name="">
+          <a:extLst>
+            <a:ext uri="{FF2B5EF4-FFF2-40B4-BE49-F238E27FC236}">
+              <a16:creationId xmlns:a16="http://schemas.microsoft.com/office/drawing/2014/main" id="{D42F7119-24B6-D2DB-BA16-FF8B68E1FE71}"/>
+            </a:ext>
+          </a:extLst>
+        </p:cNvPr>
+        <p:cNvGrpSpPr/>
+        <p:nvPr/>
+      </p:nvGrpSpPr>
+      <p:grpSpPr>
+        <a:xfrm>
+          <a:off x="0" y="0"/>
+          <a:ext cx="0" cy="0"/>
+          <a:chOff x="0" y="0"/>
+          <a:chExt cx="0" cy="0"/>
+        </a:xfrm>
+      </p:grpSpPr>
+      <p:sp>
+        <p:nvSpPr>
+          <p:cNvPr id="2" name="Titel 1">
+            <a:extLst>
+              <a:ext uri="{FF2B5EF4-FFF2-40B4-BE49-F238E27FC236}">
+                <a16:creationId xmlns:a16="http://schemas.microsoft.com/office/drawing/2014/main" id="{CE19303A-6C64-B42A-B22E-C575DA323E4E}"/>
+              </a:ext>
+            </a:extLst>
+          </p:cNvPr>
+          <p:cNvSpPr>
+            <a:spLocks noGrp="1"/>
+          </p:cNvSpPr>
+          <p:nvPr>
+            <p:ph type="title"/>
+          </p:nvPr>
+        </p:nvSpPr>
+        <p:spPr/>
+        <p:txBody>
+          <a:bodyPr/>
+          <a:lstStyle/>
+          <a:p>
+            <a:r>
+              <a:rPr lang="de-DE" dirty="0"/>
+              <a:t>Nutzwertvergleich Easy-Problem</a:t>
+            </a:r>
+          </a:p>
+        </p:txBody>
+      </p:sp>
+      <p:pic>
+        <p:nvPicPr>
+          <p:cNvPr id="8" name="Inhaltsplatzhalter 7">
+            <a:extLst>
+              <a:ext uri="{FF2B5EF4-FFF2-40B4-BE49-F238E27FC236}">
+                <a16:creationId xmlns:a16="http://schemas.microsoft.com/office/drawing/2014/main" id="{8BBCFB51-2DA5-DE7E-6860-BB3D133BB932}"/>
+              </a:ext>
+            </a:extLst>
+          </p:cNvPr>
+          <p:cNvPicPr>
+            <a:picLocks noGrp="1" noChangeAspect="1"/>
+          </p:cNvPicPr>
+          <p:nvPr>
+            <p:ph idx="1"/>
+          </p:nvPr>
+        </p:nvPicPr>
+        <p:blipFill>
+          <a:blip r:embed="rId2">
+            <a:extLst>
+              <a:ext uri="{28A0092B-C50C-407E-A947-70E740481C1C}">
+                <a14:useLocalDpi xmlns:a14="http://schemas.microsoft.com/office/drawing/2010/main" val="0"/>
+              </a:ext>
+            </a:extLst>
+          </a:blip>
+          <a:srcRect/>
+          <a:stretch/>
+        </p:blipFill>
+        <p:spPr>
+          <a:xfrm>
+            <a:off x="838200" y="1847850"/>
+            <a:ext cx="6834718" cy="4351338"/>
+          </a:xfrm>
+          <a:prstGeom prst="rect">
+            <a:avLst/>
+          </a:prstGeom>
+        </p:spPr>
+      </p:pic>
+      <p:sp>
+        <p:nvSpPr>
+          <p:cNvPr id="4" name="Datumsplatzhalter 3">
+            <a:extLst>
+              <a:ext uri="{FF2B5EF4-FFF2-40B4-BE49-F238E27FC236}">
+                <a16:creationId xmlns:a16="http://schemas.microsoft.com/office/drawing/2014/main" id="{73C46C0A-FD65-91E8-4591-86D9036388FA}"/>
+              </a:ext>
+            </a:extLst>
+          </p:cNvPr>
+          <p:cNvSpPr>
+            <a:spLocks noGrp="1"/>
+          </p:cNvSpPr>
+          <p:nvPr>
+            <p:ph type="dt" sz="half" idx="10"/>
+          </p:nvPr>
+        </p:nvSpPr>
+        <p:spPr/>
+        <p:txBody>
+          <a:bodyPr/>
+          <a:lstStyle/>
+          <a:p>
+            <a:r>
+              <a:rPr lang="de-DE"/>
+              <a:t>22.03.2025</a:t>
+            </a:r>
+          </a:p>
+        </p:txBody>
+      </p:sp>
+      <p:sp>
+        <p:nvSpPr>
+          <p:cNvPr id="5" name="Fußzeilenplatzhalter 4">
+            <a:extLst>
+              <a:ext uri="{FF2B5EF4-FFF2-40B4-BE49-F238E27FC236}">
+                <a16:creationId xmlns:a16="http://schemas.microsoft.com/office/drawing/2014/main" id="{8F68C919-4434-1C73-54A5-22FB209F8A4F}"/>
+              </a:ext>
+            </a:extLst>
+          </p:cNvPr>
+          <p:cNvSpPr>
+            <a:spLocks noGrp="1"/>
+          </p:cNvSpPr>
+          <p:nvPr>
+            <p:ph type="ftr" sz="quarter" idx="11"/>
+          </p:nvPr>
+        </p:nvSpPr>
+        <p:spPr/>
+        <p:txBody>
+          <a:bodyPr/>
+          <a:lstStyle/>
+          <a:p>
+            <a:r>
+              <a:rPr lang="de-DE"/>
+              <a:t>Niko Kläsener</a:t>
+            </a:r>
+          </a:p>
+        </p:txBody>
+      </p:sp>
+      <p:sp>
+        <p:nvSpPr>
+          <p:cNvPr id="6" name="Foliennummernplatzhalter 5">
+            <a:extLst>
+              <a:ext uri="{FF2B5EF4-FFF2-40B4-BE49-F238E27FC236}">
+                <a16:creationId xmlns:a16="http://schemas.microsoft.com/office/drawing/2014/main" id="{5405844F-A241-D7B3-B734-DE4A1EE46DE0}"/>
+              </a:ext>
+            </a:extLst>
+          </p:cNvPr>
+          <p:cNvSpPr>
+            <a:spLocks noGrp="1"/>
+          </p:cNvSpPr>
+          <p:nvPr>
+            <p:ph type="sldNum" sz="quarter" idx="12"/>
+          </p:nvPr>
+        </p:nvSpPr>
+        <p:spPr/>
+        <p:txBody>
+          <a:bodyPr/>
+          <a:lstStyle/>
+          <a:p>
+            <a:fld id="{F20E45F0-5197-4D99-A0B0-CC09E9235134}" type="slidenum">
+              <a:rPr lang="de-DE" smtClean="0"/>
+              <a:t>8</a:t>
+            </a:fld>
+            <a:endParaRPr lang="de-DE"/>
+          </a:p>
+        </p:txBody>
+      </p:sp>
+      <p:sp>
+        <p:nvSpPr>
+          <p:cNvPr id="3" name="Textfeld 2">
+            <a:extLst>
+              <a:ext uri="{FF2B5EF4-FFF2-40B4-BE49-F238E27FC236}">
+                <a16:creationId xmlns:a16="http://schemas.microsoft.com/office/drawing/2014/main" id="{63281457-D136-1A63-F2D7-B4801B290DB8}"/>
+              </a:ext>
+            </a:extLst>
+          </p:cNvPr>
+          <p:cNvSpPr txBox="1"/>
+          <p:nvPr/>
+        </p:nvSpPr>
+        <p:spPr>
+          <a:xfrm>
+            <a:off x="8153400" y="2606109"/>
+            <a:ext cx="2990850" cy="1200329"/>
+          </a:xfrm>
+          <a:prstGeom prst="rect">
+            <a:avLst/>
+          </a:prstGeom>
+          <a:noFill/>
+        </p:spPr>
+        <p:txBody>
+          <a:bodyPr wrap="square" rtlCol="0">
+            <a:spAutoFit/>
+          </a:bodyPr>
+          <a:lstStyle/>
+          <a:p>
+            <a:r>
+              <a:rPr lang="de-DE" b="1" dirty="0"/>
+              <a:t>Easy-Problem:</a:t>
+            </a:r>
+          </a:p>
+          <a:p>
+            <a:pPr marL="285750" indent="-285750">
+              <a:buFont typeface="Wingdings" panose="05000000000000000000" pitchFamily="2" charset="2"/>
+              <a:buChar char="§"/>
+            </a:pPr>
+            <a:r>
+              <a:rPr lang="de-DE" b="1" dirty="0"/>
+              <a:t>400 Items</a:t>
+            </a:r>
+          </a:p>
+          <a:p>
+            <a:pPr marL="285750" indent="-285750">
+              <a:buFont typeface="Wingdings" panose="05000000000000000000" pitchFamily="2" charset="2"/>
+              <a:buChar char="§"/>
+            </a:pPr>
+            <a:r>
+              <a:rPr lang="de-DE" b="1" dirty="0"/>
+              <a:t>1.000.000 Kapazität</a:t>
+            </a:r>
+          </a:p>
+          <a:p>
+            <a:pPr marL="285750" indent="-285750">
+              <a:buFont typeface="Wingdings" panose="05000000000000000000" pitchFamily="2" charset="2"/>
+              <a:buChar char="§"/>
+            </a:pPr>
+            <a:r>
+              <a:rPr lang="de-DE" b="1" dirty="0"/>
+              <a:t>4 Gruppen</a:t>
+            </a:r>
+          </a:p>
+        </p:txBody>
+      </p:sp>
+      <p:sp>
+        <p:nvSpPr>
+          <p:cNvPr id="7" name="Textfeld 6">
+            <a:extLst>
+              <a:ext uri="{FF2B5EF4-FFF2-40B4-BE49-F238E27FC236}">
+                <a16:creationId xmlns:a16="http://schemas.microsoft.com/office/drawing/2014/main" id="{95B4E1EB-B5BB-3FBA-04AE-035423E7056E}"/>
+              </a:ext>
+            </a:extLst>
+          </p:cNvPr>
+          <p:cNvSpPr txBox="1"/>
+          <p:nvPr/>
+        </p:nvSpPr>
+        <p:spPr>
+          <a:xfrm>
+            <a:off x="8153400" y="4240600"/>
+            <a:ext cx="3409950" cy="1477328"/>
+          </a:xfrm>
+          <a:prstGeom prst="rect">
+            <a:avLst/>
+          </a:prstGeom>
+          <a:noFill/>
+        </p:spPr>
+        <p:txBody>
+          <a:bodyPr wrap="square" rtlCol="0">
+            <a:spAutoFit/>
+          </a:bodyPr>
+          <a:lstStyle/>
+          <a:p>
+            <a:r>
+              <a:rPr lang="de-DE" b="1" dirty="0"/>
+              <a:t>Ergebnis:</a:t>
+            </a:r>
+          </a:p>
+          <a:p>
+            <a:pPr marL="285750" indent="-285750">
+              <a:buFont typeface="Wingdings" panose="05000000000000000000" pitchFamily="2" charset="2"/>
+              <a:buChar char="§"/>
+            </a:pPr>
+            <a:r>
+              <a:rPr lang="de-DE" b="1" dirty="0"/>
+              <a:t>Beste: 	99,91%</a:t>
+            </a:r>
+          </a:p>
+          <a:p>
+            <a:pPr marL="285750" indent="-285750">
+              <a:buFont typeface="Wingdings" panose="05000000000000000000" pitchFamily="2" charset="2"/>
+              <a:buChar char="§"/>
+            </a:pPr>
+            <a:r>
+              <a:rPr lang="de-DE" b="1" dirty="0"/>
+              <a:t>Mittlere: 	99,96%</a:t>
+            </a:r>
+          </a:p>
+          <a:p>
+            <a:pPr marL="285750" indent="-285750">
+              <a:buFont typeface="Wingdings" panose="05000000000000000000" pitchFamily="2" charset="2"/>
+              <a:buChar char="§"/>
+            </a:pPr>
+            <a:r>
+              <a:rPr lang="de-DE" b="1" dirty="0"/>
+              <a:t>Schlechteste:	99,66%</a:t>
+            </a:r>
+          </a:p>
+          <a:p>
+            <a:pPr marL="285750" indent="-285750">
+              <a:buFont typeface="Wingdings" panose="05000000000000000000" pitchFamily="2" charset="2"/>
+              <a:buChar char="§"/>
+            </a:pPr>
+            <a:endParaRPr lang="de-DE" dirty="0"/>
+          </a:p>
+        </p:txBody>
+      </p:sp>
+    </p:spTree>
+    <p:extLst>
+      <p:ext uri="{BB962C8B-B14F-4D97-AF65-F5344CB8AC3E}">
+        <p14:creationId xmlns:p14="http://schemas.microsoft.com/office/powerpoint/2010/main" val="284479213"/>
+      </p:ext>
+    </p:extLst>
+  </p:cSld>
+  <p:clrMapOvr>
+    <a:masterClrMapping/>
+  </p:clrMapOvr>
+</p:sld>
+</file>
+
+<file path=ppt/slides/slide9.xml><?xml version="1.0" encoding="utf-8"?>
 <p:sld xmlns:a="http://schemas.openxmlformats.org/drawingml/2006/main" xmlns:r="http://schemas.openxmlformats.org/officeDocument/2006/relationships" xmlns:p="http://schemas.openxmlformats.org/presentationml/2006/main">
   <p:cSld>
     <p:spTree>
@@ -7250,7 +8601,7 @@
           <p:cNvPr id="2" name="Titel 1">
             <a:extLst>
               <a:ext uri="{FF2B5EF4-FFF2-40B4-BE49-F238E27FC236}">
-                <a16:creationId xmlns:a16="http://schemas.microsoft.com/office/drawing/2014/main" id="{DE86CDD5-F3A8-1E49-03B4-ABAC4E69630F}"/>
+                <a16:creationId xmlns:a16="http://schemas.microsoft.com/office/drawing/2014/main" id="{6BB030AB-786E-C531-12A7-749F70850164}"/>
               </a:ext>
             </a:extLst>
           </p:cNvPr>
@@ -7268,55 +8619,153 @@
           <a:p>
             <a:r>
               <a:rPr lang="de-DE" dirty="0"/>
-              <a:t>Item-Auswahl</a:t>
-            </a:r>
-          </a:p>
-        </p:txBody>
-      </p:sp>
-      <p:pic>
-        <p:nvPicPr>
-          <p:cNvPr id="8" name="Inhaltsplatzhalter 7">
-            <a:extLst>
-              <a:ext uri="{FF2B5EF4-FFF2-40B4-BE49-F238E27FC236}">
-                <a16:creationId xmlns:a16="http://schemas.microsoft.com/office/drawing/2014/main" id="{CCD849A5-AE97-5B6A-16ED-2BC4C72CF5BC}"/>
-              </a:ext>
-            </a:extLst>
-          </p:cNvPr>
-          <p:cNvPicPr>
-            <a:picLocks noGrp="1" noChangeAspect="1"/>
-          </p:cNvPicPr>
-          <p:nvPr>
-            <p:ph idx="1"/>
-          </p:nvPr>
-        </p:nvPicPr>
-        <p:blipFill>
-          <a:blip r:embed="rId2">
-            <a:extLst>
-              <a:ext uri="{28A0092B-C50C-407E-A947-70E740481C1C}">
-                <a14:useLocalDpi xmlns:a14="http://schemas.microsoft.com/office/drawing/2010/main" val="0"/>
-              </a:ext>
-            </a:extLst>
-          </a:blip>
-          <a:stretch>
-            <a:fillRect/>
-          </a:stretch>
-        </p:blipFill>
-        <p:spPr>
-          <a:xfrm>
-            <a:off x="1059100" y="1825625"/>
-            <a:ext cx="10073799" cy="4351338"/>
-          </a:xfrm>
-          <a:prstGeom prst="rect">
-            <a:avLst/>
-          </a:prstGeom>
-        </p:spPr>
-      </p:pic>
-      <p:sp>
-        <p:nvSpPr>
-          <p:cNvPr id="4" name="Datumsplatzhalter 3">
-            <a:extLst>
-              <a:ext uri="{FF2B5EF4-FFF2-40B4-BE49-F238E27FC236}">
-                <a16:creationId xmlns:a16="http://schemas.microsoft.com/office/drawing/2014/main" id="{E50407AF-A5BD-50CE-FDF3-BF40706A411F}"/>
+              <a:t>Fazit</a:t>
+            </a:r>
+          </a:p>
+        </p:txBody>
+      </p:sp>
+      <mc:AlternateContent xmlns:mc="http://schemas.openxmlformats.org/markup-compatibility/2006">
+        <mc:Choice xmlns:a14="http://schemas.microsoft.com/office/drawing/2010/main" Requires="a14">
+          <p:sp>
+            <p:nvSpPr>
+              <p:cNvPr id="5" name="Textplatzhalter 4">
+                <a:extLst>
+                  <a:ext uri="{FF2B5EF4-FFF2-40B4-BE49-F238E27FC236}">
+                    <a16:creationId xmlns:a16="http://schemas.microsoft.com/office/drawing/2014/main" id="{874A7A65-C7F4-F6C9-5AE4-858DEE4E2960}"/>
+                  </a:ext>
+                </a:extLst>
+              </p:cNvPr>
+              <p:cNvSpPr>
+                <a:spLocks noGrp="1"/>
+              </p:cNvSpPr>
+              <p:nvPr>
+                <p:ph type="body" sz="quarter" idx="3"/>
+              </p:nvPr>
+            </p:nvSpPr>
+            <p:spPr/>
+            <p:txBody>
+              <a:bodyPr/>
+              <a:lstStyle/>
+              <a:p>
+                <a:r>
+                  <a:rPr lang="de-DE" dirty="0"/>
+                  <a:t>Einfluss vom Großen </a:t>
+                </a:r>
+                <a14:m>
+                  <m:oMath xmlns:m="http://schemas.openxmlformats.org/officeDocument/2006/math">
+                    <m:r>
+                      <a:rPr lang="de-DE" i="1">
+                        <a:latin typeface="Cambria Math" panose="02040503050406030204" pitchFamily="18" charset="0"/>
+                        <a:ea typeface="Cambria Math" panose="02040503050406030204" pitchFamily="18" charset="0"/>
+                      </a:rPr>
+                      <m:t>𝛽</m:t>
+                    </m:r>
+                  </m:oMath>
+                </a14:m>
+                <a:endParaRPr lang="de-DE" dirty="0"/>
+              </a:p>
+            </p:txBody>
+          </p:sp>
+        </mc:Choice>
+        <mc:Fallback>
+          <p:sp>
+            <p:nvSpPr>
+              <p:cNvPr id="5" name="Textplatzhalter 4">
+                <a:extLst>
+                  <a:ext uri="{FF2B5EF4-FFF2-40B4-BE49-F238E27FC236}">
+                    <a16:creationId xmlns:a16="http://schemas.microsoft.com/office/drawing/2014/main" id="{874A7A65-C7F4-F6C9-5AE4-858DEE4E2960}"/>
+                  </a:ext>
+                </a:extLst>
+              </p:cNvPr>
+              <p:cNvSpPr>
+                <a:spLocks noGrp="1" noRot="1" noChangeAspect="1" noMove="1" noResize="1" noEditPoints="1" noAdjustHandles="1" noChangeArrowheads="1" noChangeShapeType="1" noTextEdit="1"/>
+              </p:cNvSpPr>
+              <p:nvPr>
+                <p:ph type="body" sz="quarter" idx="3"/>
+              </p:nvPr>
+            </p:nvSpPr>
+            <p:spPr>
+              <a:blipFill>
+                <a:blip r:embed="rId2"/>
+                <a:stretch>
+                  <a:fillRect l="-1882" b="-17778"/>
+                </a:stretch>
+              </a:blipFill>
+            </p:spPr>
+            <p:txBody>
+              <a:bodyPr/>
+              <a:lstStyle/>
+              <a:p>
+                <a:r>
+                  <a:rPr lang="de-DE">
+                    <a:noFill/>
+                  </a:rPr>
+                  <a:t> </a:t>
+                </a:r>
+              </a:p>
+            </p:txBody>
+          </p:sp>
+        </mc:Fallback>
+      </mc:AlternateContent>
+      <p:sp>
+        <p:nvSpPr>
+          <p:cNvPr id="6" name="Inhaltsplatzhalter 5">
+            <a:extLst>
+              <a:ext uri="{FF2B5EF4-FFF2-40B4-BE49-F238E27FC236}">
+                <a16:creationId xmlns:a16="http://schemas.microsoft.com/office/drawing/2014/main" id="{27CF4302-EE10-DEB8-57DC-0DE63F780452}"/>
+              </a:ext>
+            </a:extLst>
+          </p:cNvPr>
+          <p:cNvSpPr>
+            <a:spLocks noGrp="1"/>
+          </p:cNvSpPr>
+          <p:nvPr>
+            <p:ph sz="quarter" idx="4"/>
+          </p:nvPr>
+        </p:nvSpPr>
+        <p:spPr/>
+        <p:txBody>
+          <a:bodyPr>
+            <a:normAutofit lnSpcReduction="10000"/>
+          </a:bodyPr>
+          <a:lstStyle/>
+          <a:p>
+            <a:r>
+              <a:rPr lang="de-DE" dirty="0"/>
+              <a:t>Ermöglicht Selektion zwischen Gegenständen mit minimalen unterschieden (z.B. 1 und 0,999)</a:t>
+            </a:r>
+          </a:p>
+          <a:p>
+            <a:pPr>
+              <a:buFont typeface="Wingdings" panose="05000000000000000000" pitchFamily="2" charset="2"/>
+              <a:buChar char="§"/>
+            </a:pPr>
+            <a:r>
+              <a:rPr lang="de-DE" dirty="0"/>
+              <a:t>Verlust der Selektion Fähigkeit bei allgemein schlechteren Gegenständen (z.B. 0,1 und 0,0999)</a:t>
+            </a:r>
+          </a:p>
+          <a:p>
+            <a:pPr>
+              <a:buFont typeface="Wingdings" panose="05000000000000000000" pitchFamily="2" charset="2"/>
+              <a:buChar char="§"/>
+            </a:pPr>
+            <a:r>
+              <a:rPr lang="de-DE" dirty="0"/>
+              <a:t>Fokussierung auf Gegenständen mit hoher Attraktivität </a:t>
+            </a:r>
+          </a:p>
+          <a:p>
+            <a:endParaRPr lang="de-DE" dirty="0"/>
+          </a:p>
+        </p:txBody>
+      </p:sp>
+      <p:sp>
+        <p:nvSpPr>
+          <p:cNvPr id="7" name="Datumsplatzhalter 6">
+            <a:extLst>
+              <a:ext uri="{FF2B5EF4-FFF2-40B4-BE49-F238E27FC236}">
+                <a16:creationId xmlns:a16="http://schemas.microsoft.com/office/drawing/2014/main" id="{6B894B29-7047-1ACA-3353-24BCA1F292EB}"/>
               </a:ext>
             </a:extLst>
           </p:cNvPr>
@@ -7341,10 +8790,10 @@
       </p:sp>
       <p:sp>
         <p:nvSpPr>
-          <p:cNvPr id="5" name="Fußzeilenplatzhalter 4">
-            <a:extLst>
-              <a:ext uri="{FF2B5EF4-FFF2-40B4-BE49-F238E27FC236}">
-                <a16:creationId xmlns:a16="http://schemas.microsoft.com/office/drawing/2014/main" id="{7411A53B-319E-FD54-9E3B-908627BD44F5}"/>
+          <p:cNvPr id="8" name="Fußzeilenplatzhalter 7">
+            <a:extLst>
+              <a:ext uri="{FF2B5EF4-FFF2-40B4-BE49-F238E27FC236}">
+                <a16:creationId xmlns:a16="http://schemas.microsoft.com/office/drawing/2014/main" id="{5981A085-1E07-22DC-7050-E4D89C38BAD6}"/>
               </a:ext>
             </a:extLst>
           </p:cNvPr>
@@ -7369,10 +8818,10 @@
       </p:sp>
       <p:sp>
         <p:nvSpPr>
-          <p:cNvPr id="6" name="Foliennummernplatzhalter 5">
-            <a:extLst>
-              <a:ext uri="{FF2B5EF4-FFF2-40B4-BE49-F238E27FC236}">
-                <a16:creationId xmlns:a16="http://schemas.microsoft.com/office/drawing/2014/main" id="{FE1E8DB6-4C98-C632-D75C-05F38D93E9EB}"/>
+          <p:cNvPr id="9" name="Foliennummernplatzhalter 8">
+            <a:extLst>
+              <a:ext uri="{FF2B5EF4-FFF2-40B4-BE49-F238E27FC236}">
+                <a16:creationId xmlns:a16="http://schemas.microsoft.com/office/drawing/2014/main" id="{86C91C11-4729-3014-9DB3-AC8059C85536}"/>
               </a:ext>
             </a:extLst>
           </p:cNvPr>
@@ -7390,16 +8839,114 @@
           <a:p>
             <a:fld id="{F20E45F0-5197-4D99-A0B0-CC09E9235134}" type="slidenum">
               <a:rPr lang="de-DE" smtClean="0"/>
-              <a:t>8</a:t>
+              <a:t>9</a:t>
             </a:fld>
-            <a:endParaRPr lang="de-DE"/>
+            <a:endParaRPr lang="de-DE" dirty="0"/>
+          </a:p>
+        </p:txBody>
+      </p:sp>
+      <p:sp>
+        <p:nvSpPr>
+          <p:cNvPr id="3" name="Textplatzhalter 2">
+            <a:extLst>
+              <a:ext uri="{FF2B5EF4-FFF2-40B4-BE49-F238E27FC236}">
+                <a16:creationId xmlns:a16="http://schemas.microsoft.com/office/drawing/2014/main" id="{F05D5584-C5F5-B21E-C1D6-CE5472F6A3BE}"/>
+              </a:ext>
+            </a:extLst>
+          </p:cNvPr>
+          <p:cNvSpPr>
+            <a:spLocks noGrp="1"/>
+          </p:cNvSpPr>
+          <p:nvPr>
+            <p:ph type="body" idx="1"/>
+          </p:nvPr>
+        </p:nvSpPr>
+        <p:spPr/>
+        <p:txBody>
+          <a:bodyPr/>
+          <a:lstStyle/>
+          <a:p>
+            <a:r>
+              <a:rPr lang="de-DE" dirty="0"/>
+              <a:t>Haupterkenntnis</a:t>
+            </a:r>
+          </a:p>
+        </p:txBody>
+      </p:sp>
+      <p:sp>
+        <p:nvSpPr>
+          <p:cNvPr id="4" name="Inhaltsplatzhalter 3">
+            <a:extLst>
+              <a:ext uri="{FF2B5EF4-FFF2-40B4-BE49-F238E27FC236}">
+                <a16:creationId xmlns:a16="http://schemas.microsoft.com/office/drawing/2014/main" id="{69979646-04D1-7A25-F6AA-E780620BB2CB}"/>
+              </a:ext>
+            </a:extLst>
+          </p:cNvPr>
+          <p:cNvSpPr>
+            <a:spLocks noGrp="1"/>
+          </p:cNvSpPr>
+          <p:nvPr>
+            <p:ph sz="half" idx="2"/>
+          </p:nvPr>
+        </p:nvSpPr>
+        <p:spPr/>
+        <p:txBody>
+          <a:bodyPr>
+            <a:normAutofit lnSpcReduction="10000"/>
+          </a:bodyPr>
+          <a:lstStyle/>
+          <a:p>
+            <a:pPr>
+              <a:buFont typeface="Wingdings" panose="05000000000000000000" pitchFamily="2" charset="2"/>
+              <a:buChar char="§"/>
+            </a:pPr>
+            <a:r>
+              <a:rPr lang="de-DE" dirty="0"/>
+              <a:t>Differenz zwischen der besten und schlechtesten Konfiguration 0,3% beim Hard-Problem</a:t>
+            </a:r>
+          </a:p>
+          <a:p>
+            <a:pPr>
+              <a:buFont typeface="Wingdings" panose="05000000000000000000" pitchFamily="2" charset="2"/>
+              <a:buChar char="§"/>
+            </a:pPr>
+            <a:r>
+              <a:rPr lang="de-DE" dirty="0"/>
+              <a:t>Beim Easy Problem Stagnation der besten Konfiguration</a:t>
+            </a:r>
+          </a:p>
+          <a:p>
+            <a:pPr>
+              <a:buFont typeface="Wingdings" panose="05000000000000000000" pitchFamily="2" charset="2"/>
+              <a:buChar char="§"/>
+            </a:pPr>
+            <a:r>
+              <a:rPr lang="de-DE" dirty="0"/>
+              <a:t>Schlechteste Konfiguration zeigt allgemein das beste und stabilste Suchverhalten </a:t>
+            </a:r>
+          </a:p>
+          <a:p>
+            <a:pPr>
+              <a:buFont typeface="Wingdings" panose="05000000000000000000" pitchFamily="2" charset="2"/>
+              <a:buChar char="§"/>
+            </a:pPr>
+            <a:endParaRPr lang="de-DE" b="0" dirty="0">
+              <a:ea typeface="Cambria Math" panose="02040503050406030204" pitchFamily="18" charset="0"/>
+            </a:endParaRPr>
+          </a:p>
+          <a:p>
+            <a:pPr lvl="1">
+              <a:buFont typeface="Wingdings" panose="05000000000000000000" pitchFamily="2" charset="2"/>
+              <a:buChar char="§"/>
+            </a:pPr>
+            <a:endParaRPr lang="de-DE" dirty="0"/>
           </a:p>
         </p:txBody>
       </p:sp>
     </p:spTree>
     <p:extLst>
       <p:ext uri="{BB962C8B-B14F-4D97-AF65-F5344CB8AC3E}">
-        <p14:creationId xmlns:p14="http://schemas.microsoft.com/office/powerpoint/2010/main" val="937536178"/>
+        <p14:creationId xmlns:p14="http://schemas.microsoft.com/office/powerpoint/2010/main" val="3694890744"/>
       </p:ext>
     </p:extLst>
   </p:cSld>

</xml_diff>